<commit_message>
Update BeatDetector genre analysis presentation
Co-Authored-By: Claude Haiku 4.5 <noreply@anthropic.com>
Claude-Session: https://claude.ai/code/session_01Q3iekmUMphri9Amv8dEWdG
</commit_message>
<xml_diff>
--- a/docs/BeatDetector_Genre_Analysis.pptx
+++ b/docs/BeatDetector_Genre_Analysis.pptx
@@ -3132,7 +3132,7 @@
               </a:defRPr>
             </a:pPr>
             <a:r>
-              <a:t>장르별 비트 정확도</a:t>
+              <a:t>K-POP 세부 장르 분류</a:t>
             </a:r>
           </a:p>
         </p:txBody>
@@ -3167,7 +3167,7 @@
               </a:defRPr>
             </a:pPr>
             <a:r>
-              <a:t>분석 리포트 (33곡 전체)</a:t>
+              <a:t>비트 정확도 분석 (33곡)</a:t>
             </a:r>
           </a:p>
         </p:txBody>
@@ -3245,7 +3245,7 @@
               </a:defRPr>
             </a:pPr>
             <a:r>
-              <a:t>장르별 곡 분류 현황 (33곡)</a:t>
+              <a:t>개선된 장르 분류 현황 (33곡)</a:t>
             </a:r>
           </a:p>
         </p:txBody>
@@ -3280,7 +3280,7 @@
               </a:defRPr>
             </a:pPr>
             <a:r>
-              <a:t>33곡을 4개 장르로 분류</a:t>
+              <a:t>K-POP을 Dance/Pop/Ballad로 세분화</a:t>
             </a:r>
           </a:p>
         </p:txBody>
@@ -3295,7 +3295,7 @@
         </p:nvGraphicFramePr>
         <p:xfrm>
           <a:off x="457200" y="1463040"/>
-          <a:ext cx="8229600" cy="1828800"/>
+          <a:ext cx="8229600" cy="2011680"/>
         </p:xfrm>
         <a:graphic>
           <a:graphicData uri="http://schemas.openxmlformats.org/drawingml/2006/table">
@@ -3309,7 +3309,7 @@
                 <a:gridCol w="2057400"/>
                 <a:gridCol w="2057400"/>
               </a:tblGrid>
-              <a:tr h="365760">
+              <a:tr h="287382">
                 <a:tc>
                   <a:txBody>
                     <a:bodyPr/>
@@ -3395,7 +3395,7 @@
                   </a:tcPr>
                 </a:tc>
               </a:tr>
-              <a:tr h="365760">
+              <a:tr h="287382">
                 <a:tc>
                   <a:txBody>
                     <a:bodyPr/>
@@ -3403,7 +3403,7 @@
                     <a:p>
                       <a:r>
                         <a:rPr sz="900"/>
-                        <a:t>K-POP</a:t>
+                        <a:t>K-POP - Dance</a:t>
                       </a:r>
                     </a:p>
                   </a:txBody>
@@ -3416,7 +3416,7 @@
                     <a:p>
                       <a:r>
                         <a:rPr sz="900"/>
-                        <a:t>18곡</a:t>
+                        <a:t>9곡</a:t>
                       </a:r>
                     </a:p>
                   </a:txBody>
@@ -3429,7 +3429,7 @@
                     <a:p>
                       <a:r>
                         <a:rPr sz="900"/>
-                        <a:t>54.5%</a:t>
+                        <a:t>27.3%</a:t>
                       </a:r>
                     </a:p>
                   </a:txBody>
@@ -3442,14 +3442,14 @@
                     <a:p>
                       <a:r>
                         <a:rPr sz="900"/>
-                        <a:t>BLACKPINK, 아일릿, aespa, Stray Kids, iKON</a:t>
+                        <a:t>에너지 넘치는 댄스곡 (BLACKPINK, aespa, Stray Kids)</a:t>
                       </a:r>
                     </a:p>
                   </a:txBody>
                   <a:tcPr/>
                 </a:tc>
               </a:tr>
-              <a:tr h="365760">
+              <a:tr h="287382">
                 <a:tc>
                   <a:txBody>
                     <a:bodyPr/>
@@ -3457,7 +3457,7 @@
                     <a:p>
                       <a:r>
                         <a:rPr sz="900"/>
-                        <a:t>POP</a:t>
+                        <a:t>K-POP - Pop</a:t>
                       </a:r>
                     </a:p>
                   </a:txBody>
@@ -3508,7 +3508,7 @@
                     <a:p>
                       <a:r>
                         <a:rPr sz="900"/>
-                        <a:t>Charlie Puth, Ed Sheeran, Good Goodbye</a:t>
+                        <a:t>중간 템포 팝곡 (아일릿, 셀럽리티)</a:t>
                       </a:r>
                     </a:p>
                   </a:txBody>
@@ -3519,7 +3519,185 @@
                   </a:tcPr>
                 </a:tc>
               </a:tr>
-              <a:tr h="365760">
+              <a:tr h="287382">
+                <a:tc>
+                  <a:txBody>
+                    <a:bodyPr/>
+                    <a:lstStyle/>
+                    <a:p>
+                      <a:r>
+                        <a:rPr sz="900"/>
+                        <a:t>K-POP - Ballad</a:t>
+                      </a:r>
+                    </a:p>
+                  </a:txBody>
+                  <a:tcPr/>
+                </a:tc>
+                <a:tc>
+                  <a:txBody>
+                    <a:bodyPr/>
+                    <a:lstStyle/>
+                    <a:p>
+                      <a:r>
+                        <a:rPr sz="900"/>
+                        <a:t>7곡</a:t>
+                      </a:r>
+                    </a:p>
+                  </a:txBody>
+                  <a:tcPr/>
+                </a:tc>
+                <a:tc>
+                  <a:txBody>
+                    <a:bodyPr/>
+                    <a:lstStyle/>
+                    <a:p>
+                      <a:r>
+                        <a:rPr sz="900"/>
+                        <a:t>21.2%</a:t>
+                      </a:r>
+                    </a:p>
+                  </a:txBody>
+                  <a:tcPr/>
+                </a:tc>
+                <a:tc>
+                  <a:txBody>
+                    <a:bodyPr/>
+                    <a:lstStyle/>
+                    <a:p>
+                      <a:r>
+                        <a:rPr sz="900"/>
+                        <a:t>감성 발라드곡 (사랑했다, Let's go see the stars)</a:t>
+                      </a:r>
+                    </a:p>
+                  </a:txBody>
+                  <a:tcPr/>
+                </a:tc>
+              </a:tr>
+              <a:tr h="287382">
+                <a:tc>
+                  <a:txBody>
+                    <a:bodyPr/>
+                    <a:lstStyle/>
+                    <a:p>
+                      <a:r>
+                        <a:rPr sz="900"/>
+                        <a:t>POP (Western)</a:t>
+                      </a:r>
+                    </a:p>
+                  </a:txBody>
+                  <a:tcPr>
+                    <a:solidFill>
+                      <a:srgbClr val="F0F0F0"/>
+                    </a:solidFill>
+                  </a:tcPr>
+                </a:tc>
+                <a:tc>
+                  <a:txBody>
+                    <a:bodyPr/>
+                    <a:lstStyle/>
+                    <a:p>
+                      <a:r>
+                        <a:rPr sz="900"/>
+                        <a:t>7곡</a:t>
+                      </a:r>
+                    </a:p>
+                  </a:txBody>
+                  <a:tcPr>
+                    <a:solidFill>
+                      <a:srgbClr val="F0F0F0"/>
+                    </a:solidFill>
+                  </a:tcPr>
+                </a:tc>
+                <a:tc>
+                  <a:txBody>
+                    <a:bodyPr/>
+                    <a:lstStyle/>
+                    <a:p>
+                      <a:r>
+                        <a:rPr sz="900"/>
+                        <a:t>21.2%</a:t>
+                      </a:r>
+                    </a:p>
+                  </a:txBody>
+                  <a:tcPr>
+                    <a:solidFill>
+                      <a:srgbClr val="F0F0F0"/>
+                    </a:solidFill>
+                  </a:tcPr>
+                </a:tc>
+                <a:tc>
+                  <a:txBody>
+                    <a:bodyPr/>
+                    <a:lstStyle/>
+                    <a:p>
+                      <a:r>
+                        <a:rPr sz="900"/>
+                        <a:t>팝/일렉트로닉 (Charlie Puth, Ed Sheeran)</a:t>
+                      </a:r>
+                    </a:p>
+                  </a:txBody>
+                  <a:tcPr>
+                    <a:solidFill>
+                      <a:srgbClr val="F0F0F0"/>
+                    </a:solidFill>
+                  </a:tcPr>
+                </a:tc>
+              </a:tr>
+              <a:tr h="287382">
+                <a:tc>
+                  <a:txBody>
+                    <a:bodyPr/>
+                    <a:lstStyle/>
+                    <a:p>
+                      <a:r>
+                        <a:rPr sz="900"/>
+                        <a:t>CLASSICAL</a:t>
+                      </a:r>
+                    </a:p>
+                  </a:txBody>
+                  <a:tcPr/>
+                </a:tc>
+                <a:tc>
+                  <a:txBody>
+                    <a:bodyPr/>
+                    <a:lstStyle/>
+                    <a:p>
+                      <a:r>
+                        <a:rPr sz="900"/>
+                        <a:t>1곡</a:t>
+                      </a:r>
+                    </a:p>
+                  </a:txBody>
+                  <a:tcPr/>
+                </a:tc>
+                <a:tc>
+                  <a:txBody>
+                    <a:bodyPr/>
+                    <a:lstStyle/>
+                    <a:p>
+                      <a:r>
+                        <a:rPr sz="900"/>
+                        <a:t>3.0%</a:t>
+                      </a:r>
+                    </a:p>
+                  </a:txBody>
+                  <a:tcPr/>
+                </a:tc>
+                <a:tc>
+                  <a:txBody>
+                    <a:bodyPr/>
+                    <a:lstStyle/>
+                    <a:p>
+                      <a:r>
+                        <a:rPr sz="900"/>
+                        <a:t>클래식 (Bach)</a:t>
+                      </a:r>
+                    </a:p>
+                  </a:txBody>
+                  <a:tcPr/>
+                </a:tc>
+              </a:tr>
+              <a:tr h="287388">
                 <a:tc>
                   <a:txBody>
                     <a:bodyPr/>
@@ -3531,60 +3709,6 @@
                       </a:r>
                     </a:p>
                   </a:txBody>
-                  <a:tcPr/>
-                </a:tc>
-                <a:tc>
-                  <a:txBody>
-                    <a:bodyPr/>
-                    <a:lstStyle/>
-                    <a:p>
-                      <a:r>
-                        <a:rPr sz="900"/>
-                        <a:t>6곡</a:t>
-                      </a:r>
-                    </a:p>
-                  </a:txBody>
-                  <a:tcPr/>
-                </a:tc>
-                <a:tc>
-                  <a:txBody>
-                    <a:bodyPr/>
-                    <a:lstStyle/>
-                    <a:p>
-                      <a:r>
-                        <a:rPr sz="900"/>
-                        <a:t>18.2%</a:t>
-                      </a:r>
-                    </a:p>
-                  </a:txBody>
-                  <a:tcPr/>
-                </a:tc>
-                <a:tc>
-                  <a:txBody>
-                    <a:bodyPr/>
-                    <a:lstStyle/>
-                    <a:p>
-                      <a:r>
-                        <a:rPr sz="900"/>
-                        <a:t>Next Level, Magnetic, Midnight Fiction, Entrance</a:t>
-                      </a:r>
-                    </a:p>
-                  </a:txBody>
-                  <a:tcPr/>
-                </a:tc>
-              </a:tr>
-              <a:tr h="365760">
-                <a:tc>
-                  <a:txBody>
-                    <a:bodyPr/>
-                    <a:lstStyle/>
-                    <a:p>
-                      <a:r>
-                        <a:rPr sz="900"/>
-                        <a:t>CLASSICAL</a:t>
-                      </a:r>
-                    </a:p>
-                  </a:txBody>
                   <a:tcPr>
                     <a:solidFill>
                       <a:srgbClr val="F0F0F0"/>
@@ -3632,7 +3756,7 @@
                     <a:p>
                       <a:r>
                         <a:rPr sz="900"/>
-                        <a:t>Bach - Brandenburg Concerto</a:t>
+                        <a:t>기타</a:t>
                       </a:r>
                     </a:p>
                   </a:txBody>
@@ -3655,7 +3779,7 @@
         </p:nvSpPr>
         <p:spPr>
           <a:xfrm>
-            <a:off x="457200" y="3474720"/>
+            <a:off x="457200" y="3566160"/>
             <a:ext cx="8229600" cy="457200"/>
           </a:xfrm>
           <a:prstGeom prst="rect">
@@ -3677,7 +3801,7 @@
               </a:defRPr>
             </a:pPr>
             <a:r>
-              <a:t>장르별 F-Measure 평균 (madmom 기준)</a:t>
+              <a:t>K-POP 세부 장르별 F-Measure 평균 (madmom 기준)</a:t>
             </a:r>
           </a:p>
         </p:txBody>
@@ -3691,8 +3815,8 @@
           <p:nvPr/>
         </p:nvGraphicFramePr>
         <p:xfrm>
-          <a:off x="457200" y="4023360"/>
-          <a:ext cx="8229600" cy="2560320"/>
+          <a:off x="457200" y="4114800"/>
+          <a:ext cx="8229600" cy="2468880"/>
         </p:xfrm>
         <a:graphic>
           <a:graphicData uri="http://schemas.openxmlformats.org/drawingml/2006/table">
@@ -3707,7 +3831,7 @@
                 <a:gridCol w="1645920"/>
                 <a:gridCol w="1645920"/>
               </a:tblGrid>
-              <a:tr h="426720">
+              <a:tr h="411480">
                 <a:tc>
                   <a:txBody>
                     <a:bodyPr/>
@@ -3814,7 +3938,7 @@
                   </a:tcPr>
                 </a:tc>
               </a:tr>
-              <a:tr h="426720">
+              <a:tr h="411480">
                 <a:tc>
                   <a:txBody>
                     <a:bodyPr/>
@@ -3822,7 +3946,7 @@
                     <a:p>
                       <a:r>
                         <a:rPr sz="900"/>
-                        <a:t>K-POP</a:t>
+                        <a:t>🎵 K-POP Dance</a:t>
                       </a:r>
                     </a:p>
                   </a:txBody>
@@ -3835,7 +3959,7 @@
                     <a:p>
                       <a:r>
                         <a:rPr sz="900"/>
-                        <a:t>0.872</a:t>
+                        <a:t>0.896</a:t>
                       </a:r>
                     </a:p>
                   </a:txBody>
@@ -3848,7 +3972,7 @@
                     <a:p>
                       <a:r>
                         <a:rPr sz="900"/>
-                        <a:t>0.909</a:t>
+                        <a:t>0.920</a:t>
                       </a:r>
                     </a:p>
                   </a:txBody>
@@ -3861,7 +3985,7 @@
                     <a:p>
                       <a:r>
                         <a:rPr sz="900"/>
-                        <a:t>+0.037</a:t>
+                        <a:t>+0.024</a:t>
                       </a:r>
                     </a:p>
                   </a:txBody>
@@ -3881,7 +4005,7 @@
                   <a:tcPr/>
                 </a:tc>
               </a:tr>
-              <a:tr h="426720">
+              <a:tr h="411480">
                 <a:tc>
                   <a:txBody>
                     <a:bodyPr/>
@@ -3889,7 +4013,7 @@
                     <a:p>
                       <a:r>
                         <a:rPr sz="900"/>
-                        <a:t>POP</a:t>
+                        <a:t>🎵 K-POP Pop</a:t>
                       </a:r>
                     </a:p>
                   </a:txBody>
@@ -3906,7 +4030,7 @@
                     <a:p>
                       <a:r>
                         <a:rPr sz="900"/>
-                        <a:t>0.813</a:t>
+                        <a:t>0.905</a:t>
                       </a:r>
                     </a:p>
                   </a:txBody>
@@ -3923,7 +4047,7 @@
                     <a:p>
                       <a:r>
                         <a:rPr sz="900"/>
-                        <a:t>0.895</a:t>
+                        <a:t>0.879</a:t>
                       </a:r>
                     </a:p>
                   </a:txBody>
@@ -3940,7 +4064,7 @@
                     <a:p>
                       <a:r>
                         <a:rPr sz="900"/>
-                        <a:t>+0.082</a:t>
+                        <a:t>+-0.026</a:t>
                       </a:r>
                     </a:p>
                   </a:txBody>
@@ -3968,7 +4092,7 @@
                   </a:tcPr>
                 </a:tc>
               </a:tr>
-              <a:tr h="426720">
+              <a:tr h="411480">
                 <a:tc>
                   <a:txBody>
                     <a:bodyPr/>
@@ -3976,7 +4100,7 @@
                     <a:p>
                       <a:r>
                         <a:rPr sz="900"/>
-                        <a:t>Others</a:t>
+                        <a:t>🎵 K-POP Ballad</a:t>
                       </a:r>
                     </a:p>
                   </a:txBody>
@@ -3989,7 +4113,7 @@
                     <a:p>
                       <a:r>
                         <a:rPr sz="900"/>
-                        <a:t>0.784</a:t>
+                        <a:t>0.772</a:t>
                       </a:r>
                     </a:p>
                   </a:txBody>
@@ -4002,7 +4126,7 @@
                     <a:p>
                       <a:r>
                         <a:rPr sz="900"/>
-                        <a:t>0.814</a:t>
+                        <a:t>0.903</a:t>
                       </a:r>
                     </a:p>
                   </a:txBody>
@@ -4015,7 +4139,7 @@
                     <a:p>
                       <a:r>
                         <a:rPr sz="900"/>
-                        <a:t>+0.030</a:t>
+                        <a:t>+0.131</a:t>
                       </a:r>
                     </a:p>
                   </a:txBody>
@@ -4028,14 +4152,14 @@
                     <a:p>
                       <a:r>
                         <a:rPr sz="900"/>
-                        <a:t>⭐⭐</a:t>
+                        <a:t>⭐⭐⭐</a:t>
                       </a:r>
                     </a:p>
                   </a:txBody>
                   <a:tcPr/>
                 </a:tc>
               </a:tr>
-              <a:tr h="426720">
+              <a:tr h="411480">
                 <a:tc>
                   <a:txBody>
                     <a:bodyPr/>
@@ -4043,15 +4167,98 @@
                     <a:p>
                       <a:r>
                         <a:rPr sz="900"/>
-                        <a:t>CLASSICAL</a:t>
-                      </a:r>
-                    </a:p>
-                  </a:txBody>
-                  <a:tcPr>
-                    <a:solidFill>
-                      <a:srgbClr val="F0F0F0"/>
-                    </a:solidFill>
-                  </a:tcPr>
+                        <a:t>🎤 POP</a:t>
+                      </a:r>
+                    </a:p>
+                  </a:txBody>
+                  <a:tcPr>
+                    <a:solidFill>
+                      <a:srgbClr val="F0F0F0"/>
+                    </a:solidFill>
+                  </a:tcPr>
+                </a:tc>
+                <a:tc>
+                  <a:txBody>
+                    <a:bodyPr/>
+                    <a:lstStyle/>
+                    <a:p>
+                      <a:r>
+                        <a:rPr sz="900"/>
+                        <a:t>0.805</a:t>
+                      </a:r>
+                    </a:p>
+                  </a:txBody>
+                  <a:tcPr>
+                    <a:solidFill>
+                      <a:srgbClr val="F0F0F0"/>
+                    </a:solidFill>
+                  </a:tcPr>
+                </a:tc>
+                <a:tc>
+                  <a:txBody>
+                    <a:bodyPr/>
+                    <a:lstStyle/>
+                    <a:p>
+                      <a:r>
+                        <a:rPr sz="900"/>
+                        <a:t>0.885</a:t>
+                      </a:r>
+                    </a:p>
+                  </a:txBody>
+                  <a:tcPr>
+                    <a:solidFill>
+                      <a:srgbClr val="F0F0F0"/>
+                    </a:solidFill>
+                  </a:tcPr>
+                </a:tc>
+                <a:tc>
+                  <a:txBody>
+                    <a:bodyPr/>
+                    <a:lstStyle/>
+                    <a:p>
+                      <a:r>
+                        <a:rPr sz="900"/>
+                        <a:t>+0.080</a:t>
+                      </a:r>
+                    </a:p>
+                  </a:txBody>
+                  <a:tcPr>
+                    <a:solidFill>
+                      <a:srgbClr val="F0F0F0"/>
+                    </a:solidFill>
+                  </a:tcPr>
+                </a:tc>
+                <a:tc>
+                  <a:txBody>
+                    <a:bodyPr/>
+                    <a:lstStyle/>
+                    <a:p>
+                      <a:r>
+                        <a:rPr sz="900"/>
+                        <a:t>⭐⭐⭐</a:t>
+                      </a:r>
+                    </a:p>
+                  </a:txBody>
+                  <a:tcPr>
+                    <a:solidFill>
+                      <a:srgbClr val="F0F0F0"/>
+                    </a:solidFill>
+                  </a:tcPr>
+                </a:tc>
+              </a:tr>
+              <a:tr h="411480">
+                <a:tc>
+                  <a:txBody>
+                    <a:bodyPr/>
+                    <a:lstStyle/>
+                    <a:p>
+                      <a:r>
+                        <a:rPr sz="900"/>
+                        <a:t>🎼 CLASSICAL</a:t>
+                      </a:r>
+                    </a:p>
+                  </a:txBody>
+                  <a:tcPr/>
                 </a:tc>
                 <a:tc>
                   <a:txBody>
@@ -4064,11 +4271,7 @@
                       </a:r>
                     </a:p>
                   </a:txBody>
-                  <a:tcPr>
-                    <a:solidFill>
-                      <a:srgbClr val="F0F0F0"/>
-                    </a:solidFill>
-                  </a:tcPr>
+                  <a:tcPr/>
                 </a:tc>
                 <a:tc>
                   <a:txBody>
@@ -4081,11 +4284,7 @@
                       </a:r>
                     </a:p>
                   </a:txBody>
-                  <a:tcPr>
-                    <a:solidFill>
-                      <a:srgbClr val="F0F0F0"/>
-                    </a:solidFill>
-                  </a:tcPr>
+                  <a:tcPr/>
                 </a:tc>
                 <a:tc>
                   <a:txBody>
@@ -4098,11 +4297,7 @@
                       </a:r>
                     </a:p>
                   </a:txBody>
-                  <a:tcPr>
-                    <a:solidFill>
-                      <a:srgbClr val="F0F0F0"/>
-                    </a:solidFill>
-                  </a:tcPr>
+                  <a:tcPr/>
                 </a:tc>
                 <a:tc>
                   <a:txBody>
@@ -4111,78 +4306,7 @@
                     <a:p>
                       <a:r>
                         <a:rPr sz="900"/>
-                        <a:t>❌ 낮음</a:t>
-                      </a:r>
-                    </a:p>
-                  </a:txBody>
-                  <a:tcPr>
-                    <a:solidFill>
-                      <a:srgbClr val="F0F0F0"/>
-                    </a:solidFill>
-                  </a:tcPr>
-                </a:tc>
-              </a:tr>
-              <a:tr h="426720">
-                <a:tc>
-                  <a:txBody>
-                    <a:bodyPr/>
-                    <a:lstStyle/>
-                    <a:p>
-                      <a:r>
-                        <a:rPr sz="900"/>
-                        <a:t>전체 평균</a:t>
-                      </a:r>
-                    </a:p>
-                  </a:txBody>
-                  <a:tcPr/>
-                </a:tc>
-                <a:tc>
-                  <a:txBody>
-                    <a:bodyPr/>
-                    <a:lstStyle/>
-                    <a:p>
-                      <a:r>
-                        <a:rPr sz="900"/>
-                        <a:t>0.859</a:t>
-                      </a:r>
-                    </a:p>
-                  </a:txBody>
-                  <a:tcPr/>
-                </a:tc>
-                <a:tc>
-                  <a:txBody>
-                    <a:bodyPr/>
-                    <a:lstStyle/>
-                    <a:p>
-                      <a:r>
-                        <a:rPr sz="900"/>
-                        <a:t>0.725</a:t>
-                      </a:r>
-                    </a:p>
-                  </a:txBody>
-                  <a:tcPr/>
-                </a:tc>
-                <a:tc>
-                  <a:txBody>
-                    <a:bodyPr/>
-                    <a:lstStyle/>
-                    <a:p>
-                      <a:r>
-                        <a:rPr sz="900"/>
-                        <a:t>+-0.134</a:t>
-                      </a:r>
-                    </a:p>
-                  </a:txBody>
-                  <a:tcPr/>
-                </a:tc>
-                <a:tc>
-                  <a:txBody>
-                    <a:bodyPr/>
-                    <a:lstStyle/>
-                    <a:p>
-                      <a:r>
-                        <a:rPr sz="900"/>
-                        <a:t>⭐⭐⭐⭐</a:t>
+                        <a:t>❌</a:t>
                       </a:r>
                     </a:p>
                   </a:txBody>
@@ -4266,7 +4390,7 @@
               </a:defRPr>
             </a:pPr>
             <a:r>
-              <a:t>🎵 K-POP 곡 분석</a:t>
+              <a:t>🎵 K-POP - Dance 곡 분석</a:t>
             </a:r>
           </a:p>
         </p:txBody>
@@ -4301,7 +4425,7 @@
               </a:defRPr>
             </a:pPr>
             <a:r>
-              <a:t>K-POP: 18곡 (madmom 기준)</a:t>
+              <a:t>K-POP - Dance: 9곡 (madmom 기준)</a:t>
             </a:r>
           </a:p>
         </p:txBody>
@@ -4316,7 +4440,7 @@
         </p:nvGraphicFramePr>
         <p:xfrm>
           <a:off x="274320" y="1371600"/>
-          <a:ext cx="4114800" cy="5029200"/>
+          <a:ext cx="8595360" cy="5029200"/>
         </p:xfrm>
         <a:graphic>
           <a:graphicData uri="http://schemas.openxmlformats.org/drawingml/2006/table">
@@ -4325,11 +4449,11 @@
                 <a:tableStyleId>{5C22544A-7EE6-4342-B048-85BDC9FD1C3A}</a:tableStyleId>
               </a:tblPr>
               <a:tblGrid>
-                <a:gridCol w="822960"/>
-                <a:gridCol w="822960"/>
-                <a:gridCol w="822960"/>
-                <a:gridCol w="822960"/>
-                <a:gridCol w="822960"/>
+                <a:gridCol w="1719072"/>
+                <a:gridCol w="1719072"/>
+                <a:gridCol w="1719072"/>
+                <a:gridCol w="1719072"/>
+                <a:gridCol w="1719072"/>
               </a:tblGrid>
               <a:tr h="502920">
                 <a:tc>
@@ -4445,7 +4569,7 @@
                     <a:lstStyle/>
                     <a:p>
                       <a:r>
-                        <a:rPr sz="800"/>
+                        <a:rPr sz="850"/>
                         <a:t>1</a:t>
                       </a:r>
                     </a:p>
@@ -4458,7 +4582,7 @@
                     <a:lstStyle/>
                     <a:p>
                       <a:r>
-                        <a:rPr sz="800"/>
+                        <a:rPr sz="850"/>
                         <a:t>LE SSERAFIM(르세라핌) 'SPAGHETTI' (4K)</a:t>
                       </a:r>
                     </a:p>
@@ -4471,7 +4595,7 @@
                     <a:lstStyle/>
                     <a:p>
                       <a:r>
-                        <a:rPr sz="800"/>
+                        <a:rPr sz="850"/>
                         <a:t>0.846</a:t>
                       </a:r>
                     </a:p>
@@ -4484,7 +4608,7 @@
                     <a:lstStyle/>
                     <a:p>
                       <a:r>
-                        <a:rPr sz="800"/>
+                        <a:rPr sz="850"/>
                         <a:t>0.944</a:t>
                       </a:r>
                     </a:p>
@@ -4497,7 +4621,7 @@
                     <a:lstStyle/>
                     <a:p>
                       <a:r>
-                        <a:rPr sz="800"/>
+                        <a:rPr sz="850"/>
                         <a:t>S</a:t>
                       </a:r>
                     </a:p>
@@ -4512,7 +4636,7 @@
                     <a:lstStyle/>
                     <a:p>
                       <a:r>
-                        <a:rPr sz="800"/>
+                        <a:rPr sz="850"/>
                         <a:t>2</a:t>
                       </a:r>
                     </a:p>
@@ -4529,7 +4653,7 @@
                     <a:lstStyle/>
                     <a:p>
                       <a:r>
-                        <a:rPr sz="800"/>
+                        <a:rPr sz="850"/>
                         <a:t>ILLIT(아일릿) 'It's Me' (4K)</a:t>
                       </a:r>
                     </a:p>
@@ -4546,7 +4670,7 @@
                     <a:lstStyle/>
                     <a:p>
                       <a:r>
-                        <a:rPr sz="800"/>
+                        <a:rPr sz="850"/>
                         <a:t>0.989</a:t>
                       </a:r>
                     </a:p>
@@ -4563,7 +4687,7 @@
                     <a:lstStyle/>
                     <a:p>
                       <a:r>
-                        <a:rPr sz="800"/>
+                        <a:rPr sz="850"/>
                         <a:t>0.987</a:t>
                       </a:r>
                     </a:p>
@@ -4580,7 +4704,7 @@
                     <a:lstStyle/>
                     <a:p>
                       <a:r>
-                        <a:rPr sz="800"/>
+                        <a:rPr sz="850"/>
                         <a:t>S</a:t>
                       </a:r>
                     </a:p>
@@ -4599,7 +4723,7 @@
                     <a:lstStyle/>
                     <a:p>
                       <a:r>
-                        <a:rPr sz="800"/>
+                        <a:rPr sz="850"/>
                         <a:t>3</a:t>
                       </a:r>
                     </a:p>
@@ -4612,47 +4736,47 @@
                     <a:lstStyle/>
                     <a:p>
                       <a:r>
-                        <a:rPr sz="800"/>
-                        <a:t>aespa 에스파 'Supernova' MV</a:t>
-                      </a:r>
-                    </a:p>
-                  </a:txBody>
-                  <a:tcPr/>
-                </a:tc>
-                <a:tc>
-                  <a:txBody>
-                    <a:bodyPr/>
-                    <a:lstStyle/>
-                    <a:p>
-                      <a:r>
-                        <a:rPr sz="800"/>
-                        <a:t>0.915</a:t>
-                      </a:r>
-                    </a:p>
-                  </a:txBody>
-                  <a:tcPr/>
-                </a:tc>
-                <a:tc>
-                  <a:txBody>
-                    <a:bodyPr/>
-                    <a:lstStyle/>
-                    <a:p>
-                      <a:r>
-                        <a:rPr sz="800"/>
-                        <a:t>0.763</a:t>
-                      </a:r>
-                    </a:p>
-                  </a:txBody>
-                  <a:tcPr/>
-                </a:tc>
-                <a:tc>
-                  <a:txBody>
-                    <a:bodyPr/>
-                    <a:lstStyle/>
-                    <a:p>
-                      <a:r>
-                        <a:rPr sz="800"/>
-                        <a:t>A</a:t>
+                        <a:rPr sz="850"/>
+                        <a:t>aespa 에스파 'Next Level' MV</a:t>
+                      </a:r>
+                    </a:p>
+                  </a:txBody>
+                  <a:tcPr/>
+                </a:tc>
+                <a:tc>
+                  <a:txBody>
+                    <a:bodyPr/>
+                    <a:lstStyle/>
+                    <a:p>
+                      <a:r>
+                        <a:rPr sz="850"/>
+                        <a:t>0.801</a:t>
+                      </a:r>
+                    </a:p>
+                  </a:txBody>
+                  <a:tcPr/>
+                </a:tc>
+                <a:tc>
+                  <a:txBody>
+                    <a:bodyPr/>
+                    <a:lstStyle/>
+                    <a:p>
+                      <a:r>
+                        <a:rPr sz="850"/>
+                        <a:t>0.840</a:t>
+                      </a:r>
+                    </a:p>
+                  </a:txBody>
+                  <a:tcPr/>
+                </a:tc>
+                <a:tc>
+                  <a:txBody>
+                    <a:bodyPr/>
+                    <a:lstStyle/>
+                    <a:p>
+                      <a:r>
+                        <a:rPr sz="850"/>
+                        <a:t>S</a:t>
                       </a:r>
                     </a:p>
                   </a:txBody>
@@ -4666,7 +4790,7 @@
                     <a:lstStyle/>
                     <a:p>
                       <a:r>
-                        <a:rPr sz="800"/>
+                        <a:rPr sz="850"/>
                         <a:t>4</a:t>
                       </a:r>
                     </a:p>
@@ -4683,59 +4807,59 @@
                     <a:lstStyle/>
                     <a:p>
                       <a:r>
-                        <a:rPr sz="800"/>
-                        <a:t>BLACKPINK - '뛰어(JUMP)' MV</a:t>
-                      </a:r>
-                    </a:p>
-                  </a:txBody>
-                  <a:tcPr>
-                    <a:solidFill>
-                      <a:srgbClr val="F0F0F0"/>
-                    </a:solidFill>
-                  </a:tcPr>
-                </a:tc>
-                <a:tc>
-                  <a:txBody>
-                    <a:bodyPr/>
-                    <a:lstStyle/>
-                    <a:p>
-                      <a:r>
-                        <a:rPr sz="800"/>
-                        <a:t>0.941</a:t>
-                      </a:r>
-                    </a:p>
-                  </a:txBody>
-                  <a:tcPr>
-                    <a:solidFill>
-                      <a:srgbClr val="F0F0F0"/>
-                    </a:solidFill>
-                  </a:tcPr>
-                </a:tc>
-                <a:tc>
-                  <a:txBody>
-                    <a:bodyPr/>
-                    <a:lstStyle/>
-                    <a:p>
-                      <a:r>
-                        <a:rPr sz="800"/>
-                        <a:t>0.927</a:t>
-                      </a:r>
-                    </a:p>
-                  </a:txBody>
-                  <a:tcPr>
-                    <a:solidFill>
-                      <a:srgbClr val="F0F0F0"/>
-                    </a:solidFill>
-                  </a:tcPr>
-                </a:tc>
-                <a:tc>
-                  <a:txBody>
-                    <a:bodyPr/>
-                    <a:lstStyle/>
-                    <a:p>
-                      <a:r>
-                        <a:rPr sz="800"/>
-                        <a:t>S</a:t>
+                        <a:rPr sz="850"/>
+                        <a:t>aespa 에스파 'Supernova' MV</a:t>
+                      </a:r>
+                    </a:p>
+                  </a:txBody>
+                  <a:tcPr>
+                    <a:solidFill>
+                      <a:srgbClr val="F0F0F0"/>
+                    </a:solidFill>
+                  </a:tcPr>
+                </a:tc>
+                <a:tc>
+                  <a:txBody>
+                    <a:bodyPr/>
+                    <a:lstStyle/>
+                    <a:p>
+                      <a:r>
+                        <a:rPr sz="850"/>
+                        <a:t>0.915</a:t>
+                      </a:r>
+                    </a:p>
+                  </a:txBody>
+                  <a:tcPr>
+                    <a:solidFill>
+                      <a:srgbClr val="F0F0F0"/>
+                    </a:solidFill>
+                  </a:tcPr>
+                </a:tc>
+                <a:tc>
+                  <a:txBody>
+                    <a:bodyPr/>
+                    <a:lstStyle/>
+                    <a:p>
+                      <a:r>
+                        <a:rPr sz="850"/>
+                        <a:t>0.763</a:t>
+                      </a:r>
+                    </a:p>
+                  </a:txBody>
+                  <a:tcPr>
+                    <a:solidFill>
+                      <a:srgbClr val="F0F0F0"/>
+                    </a:solidFill>
+                  </a:tcPr>
+                </a:tc>
+                <a:tc>
+                  <a:txBody>
+                    <a:bodyPr/>
+                    <a:lstStyle/>
+                    <a:p>
+                      <a:r>
+                        <a:rPr sz="850"/>
+                        <a:t>A</a:t>
                       </a:r>
                     </a:p>
                   </a:txBody>
@@ -4753,7 +4877,7 @@
                     <a:lstStyle/>
                     <a:p>
                       <a:r>
-                        <a:rPr sz="800"/>
+                        <a:rPr sz="850"/>
                         <a:t>5</a:t>
                       </a:r>
                     </a:p>
@@ -4766,46 +4890,46 @@
                     <a:lstStyle/>
                     <a:p>
                       <a:r>
-                        <a:rPr sz="800"/>
-                        <a:t>ILLIT (아일릿) 'Lucky Girl Syndrome' O..</a:t>
-                      </a:r>
-                    </a:p>
-                  </a:txBody>
-                  <a:tcPr/>
-                </a:tc>
-                <a:tc>
-                  <a:txBody>
-                    <a:bodyPr/>
-                    <a:lstStyle/>
-                    <a:p>
-                      <a:r>
-                        <a:rPr sz="800"/>
-                        <a:t>0.967</a:t>
-                      </a:r>
-                    </a:p>
-                  </a:txBody>
-                  <a:tcPr/>
-                </a:tc>
-                <a:tc>
-                  <a:txBody>
-                    <a:bodyPr/>
-                    <a:lstStyle/>
-                    <a:p>
-                      <a:r>
-                        <a:rPr sz="800"/>
-                        <a:t>0.971</a:t>
-                      </a:r>
-                    </a:p>
-                  </a:txBody>
-                  <a:tcPr/>
-                </a:tc>
-                <a:tc>
-                  <a:txBody>
-                    <a:bodyPr/>
-                    <a:lstStyle/>
-                    <a:p>
-                      <a:r>
-                        <a:rPr sz="800"/>
+                        <a:rPr sz="850"/>
+                        <a:t>BLACKPINK - '뛰어(JUMP)' MV</a:t>
+                      </a:r>
+                    </a:p>
+                  </a:txBody>
+                  <a:tcPr/>
+                </a:tc>
+                <a:tc>
+                  <a:txBody>
+                    <a:bodyPr/>
+                    <a:lstStyle/>
+                    <a:p>
+                      <a:r>
+                        <a:rPr sz="850"/>
+                        <a:t>0.941</a:t>
+                      </a:r>
+                    </a:p>
+                  </a:txBody>
+                  <a:tcPr/>
+                </a:tc>
+                <a:tc>
+                  <a:txBody>
+                    <a:bodyPr/>
+                    <a:lstStyle/>
+                    <a:p>
+                      <a:r>
+                        <a:rPr sz="850"/>
+                        <a:t>0.927</a:t>
+                      </a:r>
+                    </a:p>
+                  </a:txBody>
+                  <a:tcPr/>
+                </a:tc>
+                <a:tc>
+                  <a:txBody>
+                    <a:bodyPr/>
+                    <a:lstStyle/>
+                    <a:p>
+                      <a:r>
+                        <a:rPr sz="850"/>
                         <a:t>S</a:t>
                       </a:r>
                     </a:p>
@@ -4820,7 +4944,7 @@
                     <a:lstStyle/>
                     <a:p>
                       <a:r>
-                        <a:rPr sz="800"/>
+                        <a:rPr sz="850"/>
                         <a:t>6</a:t>
                       </a:r>
                     </a:p>
@@ -4837,58 +4961,58 @@
                     <a:lstStyle/>
                     <a:p>
                       <a:r>
-                        <a:rPr sz="800"/>
-                        <a:t>Almond Chocolate</a:t>
-                      </a:r>
-                    </a:p>
-                  </a:txBody>
-                  <a:tcPr>
-                    <a:solidFill>
-                      <a:srgbClr val="F0F0F0"/>
-                    </a:solidFill>
-                  </a:tcPr>
-                </a:tc>
-                <a:tc>
-                  <a:txBody>
-                    <a:bodyPr/>
-                    <a:lstStyle/>
-                    <a:p>
-                      <a:r>
-                        <a:rPr sz="800"/>
-                        <a:t>0.981</a:t>
-                      </a:r>
-                    </a:p>
-                  </a:txBody>
-                  <a:tcPr>
-                    <a:solidFill>
-                      <a:srgbClr val="F0F0F0"/>
-                    </a:solidFill>
-                  </a:tcPr>
-                </a:tc>
-                <a:tc>
-                  <a:txBody>
-                    <a:bodyPr/>
-                    <a:lstStyle/>
-                    <a:p>
-                      <a:r>
-                        <a:rPr sz="800"/>
-                        <a:t>0.999</a:t>
-                      </a:r>
-                    </a:p>
-                  </a:txBody>
-                  <a:tcPr>
-                    <a:solidFill>
-                      <a:srgbClr val="F0F0F0"/>
-                    </a:solidFill>
-                  </a:tcPr>
-                </a:tc>
-                <a:tc>
-                  <a:txBody>
-                    <a:bodyPr/>
-                    <a:lstStyle/>
-                    <a:p>
-                      <a:r>
-                        <a:rPr sz="800"/>
+                        <a:rPr sz="850"/>
+                        <a:t>Stray Kids 神메뉴(God's Menu) MV</a:t>
+                      </a:r>
+                    </a:p>
+                  </a:txBody>
+                  <a:tcPr>
+                    <a:solidFill>
+                      <a:srgbClr val="F0F0F0"/>
+                    </a:solidFill>
+                  </a:tcPr>
+                </a:tc>
+                <a:tc>
+                  <a:txBody>
+                    <a:bodyPr/>
+                    <a:lstStyle/>
+                    <a:p>
+                      <a:r>
+                        <a:rPr sz="850"/>
+                        <a:t>0.947</a:t>
+                      </a:r>
+                    </a:p>
+                  </a:txBody>
+                  <a:tcPr>
+                    <a:solidFill>
+                      <a:srgbClr val="F0F0F0"/>
+                    </a:solidFill>
+                  </a:tcPr>
+                </a:tc>
+                <a:tc>
+                  <a:txBody>
+                    <a:bodyPr/>
+                    <a:lstStyle/>
+                    <a:p>
+                      <a:r>
+                        <a:rPr sz="850"/>
+                        <a:t>0.942</a:t>
+                      </a:r>
+                    </a:p>
+                  </a:txBody>
+                  <a:tcPr>
+                    <a:solidFill>
+                      <a:srgbClr val="F0F0F0"/>
+                    </a:solidFill>
+                  </a:tcPr>
+                </a:tc>
+                <a:tc>
+                  <a:txBody>
+                    <a:bodyPr/>
+                    <a:lstStyle/>
+                    <a:p>
+                      <a:r>
+                        <a:rPr sz="850"/>
                         <a:t>S</a:t>
                       </a:r>
                     </a:p>
@@ -4907,7 +5031,7 @@
                     <a:lstStyle/>
                     <a:p>
                       <a:r>
-                        <a:rPr sz="800"/>
+                        <a:rPr sz="850"/>
                         <a:t>7</a:t>
                       </a:r>
                     </a:p>
@@ -4920,46 +5044,46 @@
                     <a:lstStyle/>
                     <a:p>
                       <a:r>
-                        <a:rPr sz="800"/>
-                        <a:t>Stray Kids 神메뉴(God's Menu) MV</a:t>
-                      </a:r>
-                    </a:p>
-                  </a:txBody>
-                  <a:tcPr/>
-                </a:tc>
-                <a:tc>
-                  <a:txBody>
-                    <a:bodyPr/>
-                    <a:lstStyle/>
-                    <a:p>
-                      <a:r>
-                        <a:rPr sz="800"/>
-                        <a:t>0.947</a:t>
-                      </a:r>
-                    </a:p>
-                  </a:txBody>
-                  <a:tcPr/>
-                </a:tc>
-                <a:tc>
-                  <a:txBody>
-                    <a:bodyPr/>
-                    <a:lstStyle/>
-                    <a:p>
-                      <a:r>
-                        <a:rPr sz="800"/>
-                        <a:t>0.942</a:t>
-                      </a:r>
-                    </a:p>
-                  </a:txBody>
-                  <a:tcPr/>
-                </a:tc>
-                <a:tc>
-                  <a:txBody>
-                    <a:bodyPr/>
-                    <a:lstStyle/>
-                    <a:p>
-                      <a:r>
-                        <a:rPr sz="800"/>
+                        <a:rPr sz="850"/>
+                        <a:t>TOMBOY</a:t>
+                      </a:r>
+                    </a:p>
+                  </a:txBody>
+                  <a:tcPr/>
+                </a:tc>
+                <a:tc>
+                  <a:txBody>
+                    <a:bodyPr/>
+                    <a:lstStyle/>
+                    <a:p>
+                      <a:r>
+                        <a:rPr sz="850"/>
+                        <a:t>0.653</a:t>
+                      </a:r>
+                    </a:p>
+                  </a:txBody>
+                  <a:tcPr/>
+                </a:tc>
+                <a:tc>
+                  <a:txBody>
+                    <a:bodyPr/>
+                    <a:lstStyle/>
+                    <a:p>
+                      <a:r>
+                        <a:rPr sz="850"/>
+                        <a:t>0.927</a:t>
+                      </a:r>
+                    </a:p>
+                  </a:txBody>
+                  <a:tcPr/>
+                </a:tc>
+                <a:tc>
+                  <a:txBody>
+                    <a:bodyPr/>
+                    <a:lstStyle/>
+                    <a:p>
+                      <a:r>
+                        <a:rPr sz="850"/>
                         <a:t>S</a:t>
                       </a:r>
                     </a:p>
@@ -4974,7 +5098,7 @@
                     <a:lstStyle/>
                     <a:p>
                       <a:r>
-                        <a:rPr sz="800"/>
+                        <a:rPr sz="850"/>
                         <a:t>8</a:t>
                       </a:r>
                     </a:p>
@@ -4991,58 +5115,58 @@
                     <a:lstStyle/>
                     <a:p>
                       <a:r>
-                        <a:rPr sz="800"/>
-                        <a:t>IYKYK (If You Know You Know)</a:t>
-                      </a:r>
-                    </a:p>
-                  </a:txBody>
-                  <a:tcPr>
-                    <a:solidFill>
-                      <a:srgbClr val="F0F0F0"/>
-                    </a:solidFill>
-                  </a:tcPr>
-                </a:tc>
-                <a:tc>
-                  <a:txBody>
-                    <a:bodyPr/>
-                    <a:lstStyle/>
-                    <a:p>
-                      <a:r>
-                        <a:rPr sz="800"/>
-                        <a:t>0.883</a:t>
-                      </a:r>
-                    </a:p>
-                  </a:txBody>
-                  <a:tcPr>
-                    <a:solidFill>
-                      <a:srgbClr val="F0F0F0"/>
-                    </a:solidFill>
-                  </a:tcPr>
-                </a:tc>
-                <a:tc>
-                  <a:txBody>
-                    <a:bodyPr/>
-                    <a:lstStyle/>
-                    <a:p>
-                      <a:r>
-                        <a:rPr sz="800"/>
-                        <a:t>0.998</a:t>
-                      </a:r>
-                    </a:p>
-                  </a:txBody>
-                  <a:tcPr>
-                    <a:solidFill>
-                      <a:srgbClr val="F0F0F0"/>
-                    </a:solidFill>
-                  </a:tcPr>
-                </a:tc>
-                <a:tc>
-                  <a:txBody>
-                    <a:bodyPr/>
-                    <a:lstStyle/>
-                    <a:p>
-                      <a:r>
-                        <a:rPr sz="800"/>
+                        <a:rPr sz="850"/>
+                        <a:t>BLACKPINK - 'Kill This Love' MV</a:t>
+                      </a:r>
+                    </a:p>
+                  </a:txBody>
+                  <a:tcPr>
+                    <a:solidFill>
+                      <a:srgbClr val="F0F0F0"/>
+                    </a:solidFill>
+                  </a:tcPr>
+                </a:tc>
+                <a:tc>
+                  <a:txBody>
+                    <a:bodyPr/>
+                    <a:lstStyle/>
+                    <a:p>
+                      <a:r>
+                        <a:rPr sz="850"/>
+                        <a:t>0.979</a:t>
+                      </a:r>
+                    </a:p>
+                  </a:txBody>
+                  <a:tcPr>
+                    <a:solidFill>
+                      <a:srgbClr val="F0F0F0"/>
+                    </a:solidFill>
+                  </a:tcPr>
+                </a:tc>
+                <a:tc>
+                  <a:txBody>
+                    <a:bodyPr/>
+                    <a:lstStyle/>
+                    <a:p>
+                      <a:r>
+                        <a:rPr sz="850"/>
+                        <a:t>0.979</a:t>
+                      </a:r>
+                    </a:p>
+                  </a:txBody>
+                  <a:tcPr>
+                    <a:solidFill>
+                      <a:srgbClr val="F0F0F0"/>
+                    </a:solidFill>
+                  </a:tcPr>
+                </a:tc>
+                <a:tc>
+                  <a:txBody>
+                    <a:bodyPr/>
+                    <a:lstStyle/>
+                    <a:p>
+                      <a:r>
+                        <a:rPr sz="850"/>
                         <a:t>S</a:t>
                       </a:r>
                     </a:p>
@@ -5061,7 +5185,7 @@
                     <a:lstStyle/>
                     <a:p>
                       <a:r>
-                        <a:rPr sz="800"/>
+                        <a:rPr sz="850"/>
                         <a:t>9</a:t>
                       </a:r>
                     </a:p>
@@ -5074,865 +5198,46 @@
                     <a:lstStyle/>
                     <a:p>
                       <a:r>
-                        <a:rPr sz="800"/>
-                        <a:t>ILLIT (아일릿) 'Cherish (My Love)' Dan..</a:t>
-                      </a:r>
-                    </a:p>
-                  </a:txBody>
-                  <a:tcPr/>
-                </a:tc>
-                <a:tc>
-                  <a:txBody>
-                    <a:bodyPr/>
-                    <a:lstStyle/>
-                    <a:p>
-                      <a:r>
-                        <a:rPr sz="800"/>
-                        <a:t>0.684</a:t>
-                      </a:r>
-                    </a:p>
-                  </a:txBody>
-                  <a:tcPr/>
-                </a:tc>
-                <a:tc>
-                  <a:txBody>
-                    <a:bodyPr/>
-                    <a:lstStyle/>
-                    <a:p>
-                      <a:r>
-                        <a:rPr sz="800"/>
-                        <a:t>0.668</a:t>
-                      </a:r>
-                    </a:p>
-                  </a:txBody>
-                  <a:tcPr/>
-                </a:tc>
-                <a:tc>
-                  <a:txBody>
-                    <a:bodyPr/>
-                    <a:lstStyle/>
-                    <a:p>
-                      <a:r>
-                        <a:rPr sz="800"/>
-                        <a:t>B</a:t>
-                      </a:r>
-                    </a:p>
-                  </a:txBody>
-                  <a:tcPr/>
-                </a:tc>
-              </a:tr>
-            </a:tbl>
-          </a:graphicData>
-        </a:graphic>
-      </p:graphicFrame>
-      <p:graphicFrame>
-        <p:nvGraphicFramePr>
-          <p:cNvPr id="5" name="Table 4"/>
-          <p:cNvGraphicFramePr>
-            <a:graphicFrameLocks noGrp="1"/>
-          </p:cNvGraphicFramePr>
-          <p:nvPr/>
-        </p:nvGraphicFramePr>
-        <p:xfrm>
-          <a:off x="4572000" y="1371600"/>
-          <a:ext cx="4297680" cy="5029200"/>
-        </p:xfrm>
-        <a:graphic>
-          <a:graphicData uri="http://schemas.openxmlformats.org/drawingml/2006/table">
-            <a:tbl>
-              <a:tblPr firstRow="1" bandRow="1">
-                <a:tableStyleId>{5C22544A-7EE6-4342-B048-85BDC9FD1C3A}</a:tableStyleId>
-              </a:tblPr>
-              <a:tblGrid>
-                <a:gridCol w="859536"/>
-                <a:gridCol w="859536"/>
-                <a:gridCol w="859536"/>
-                <a:gridCol w="859536"/>
-                <a:gridCol w="859536"/>
-              </a:tblGrid>
-              <a:tr h="502920">
-                <a:tc>
-                  <a:txBody>
-                    <a:bodyPr/>
-                    <a:lstStyle/>
-                    <a:p>
-                      <a:r>
-                        <a:rPr b="1" sz="1000">
-                          <a:solidFill>
-                            <a:srgbClr val="FFFFFF"/>
-                          </a:solidFill>
-                        </a:rPr>
-                        <a:t>#</a:t>
-                      </a:r>
-                    </a:p>
-                  </a:txBody>
-                  <a:tcPr>
-                    <a:solidFill>
-                      <a:srgbClr val="0066CC"/>
-                    </a:solidFill>
-                  </a:tcPr>
-                </a:tc>
-                <a:tc>
-                  <a:txBody>
-                    <a:bodyPr/>
-                    <a:lstStyle/>
-                    <a:p>
-                      <a:r>
-                        <a:rPr b="1" sz="1000">
-                          <a:solidFill>
-                            <a:srgbClr val="FFFFFF"/>
-                          </a:solidFill>
-                        </a:rPr>
-                        <a:t>곡 제목</a:t>
-                      </a:r>
-                    </a:p>
-                  </a:txBody>
-                  <a:tcPr>
-                    <a:solidFill>
-                      <a:srgbClr val="0066CC"/>
-                    </a:solidFill>
-                  </a:tcPr>
-                </a:tc>
-                <a:tc>
-                  <a:txBody>
-                    <a:bodyPr/>
-                    <a:lstStyle/>
-                    <a:p>
-                      <a:r>
-                        <a:rPr b="1" sz="1000">
-                          <a:solidFill>
-                            <a:srgbClr val="FFFFFF"/>
-                          </a:solidFill>
-                        </a:rPr>
-                        <a:t>V1</a:t>
-                      </a:r>
-                    </a:p>
-                  </a:txBody>
-                  <a:tcPr>
-                    <a:solidFill>
-                      <a:srgbClr val="0066CC"/>
-                    </a:solidFill>
-                  </a:tcPr>
-                </a:tc>
-                <a:tc>
-                  <a:txBody>
-                    <a:bodyPr/>
-                    <a:lstStyle/>
-                    <a:p>
-                      <a:r>
-                        <a:rPr b="1" sz="1000">
-                          <a:solidFill>
-                            <a:srgbClr val="FFFFFF"/>
-                          </a:solidFill>
-                        </a:rPr>
-                        <a:t>V2</a:t>
-                      </a:r>
-                    </a:p>
-                  </a:txBody>
-                  <a:tcPr>
-                    <a:solidFill>
-                      <a:srgbClr val="0066CC"/>
-                    </a:solidFill>
-                  </a:tcPr>
-                </a:tc>
-                <a:tc>
-                  <a:txBody>
-                    <a:bodyPr/>
-                    <a:lstStyle/>
-                    <a:p>
-                      <a:r>
-                        <a:rPr b="1" sz="1000">
-                          <a:solidFill>
-                            <a:srgbClr val="FFFFFF"/>
-                          </a:solidFill>
-                        </a:rPr>
-                        <a:t>Grade</a:t>
-                      </a:r>
-                    </a:p>
-                  </a:txBody>
-                  <a:tcPr>
-                    <a:solidFill>
-                      <a:srgbClr val="0066CC"/>
-                    </a:solidFill>
-                  </a:tcPr>
-                </a:tc>
-              </a:tr>
-              <a:tr h="502920">
-                <a:tc>
-                  <a:txBody>
-                    <a:bodyPr/>
-                    <a:lstStyle/>
-                    <a:p>
-                      <a:r>
-                        <a:rPr sz="800"/>
-                        <a:t>10</a:t>
-                      </a:r>
-                    </a:p>
-                  </a:txBody>
-                  <a:tcPr/>
-                </a:tc>
-                <a:tc>
-                  <a:txBody>
-                    <a:bodyPr/>
-                    <a:lstStyle/>
-                    <a:p>
-                      <a:r>
-                        <a:rPr sz="800"/>
-                        <a:t>02_Magnetic_ILLIT</a:t>
-                      </a:r>
-                    </a:p>
-                  </a:txBody>
-                  <a:tcPr/>
-                </a:tc>
-                <a:tc>
-                  <a:txBody>
-                    <a:bodyPr/>
-                    <a:lstStyle/>
-                    <a:p>
-                      <a:r>
-                        <a:rPr sz="800"/>
-                        <a:t>0.470</a:t>
-                      </a:r>
-                    </a:p>
-                  </a:txBody>
-                  <a:tcPr/>
-                </a:tc>
-                <a:tc>
-                  <a:txBody>
-                    <a:bodyPr/>
-                    <a:lstStyle/>
-                    <a:p>
-                      <a:r>
-                        <a:rPr sz="800"/>
-                        <a:t>0.739</a:t>
-                      </a:r>
-                    </a:p>
-                  </a:txBody>
-                  <a:tcPr/>
-                </a:tc>
-                <a:tc>
-                  <a:txBody>
-                    <a:bodyPr/>
-                    <a:lstStyle/>
-                    <a:p>
-                      <a:r>
-                        <a:rPr sz="800"/>
-                        <a:t>A</a:t>
-                      </a:r>
-                    </a:p>
-                  </a:txBody>
-                  <a:tcPr/>
-                </a:tc>
-              </a:tr>
-              <a:tr h="502920">
-                <a:tc>
-                  <a:txBody>
-                    <a:bodyPr/>
-                    <a:lstStyle/>
-                    <a:p>
-                      <a:r>
-                        <a:rPr sz="800"/>
-                        <a:t>11</a:t>
-                      </a:r>
-                    </a:p>
-                  </a:txBody>
-                  <a:tcPr>
-                    <a:solidFill>
-                      <a:srgbClr val="F0F0F0"/>
-                    </a:solidFill>
-                  </a:tcPr>
-                </a:tc>
-                <a:tc>
-                  <a:txBody>
-                    <a:bodyPr/>
-                    <a:lstStyle/>
-                    <a:p>
-                      <a:r>
-                        <a:rPr sz="800"/>
-                        <a:t>모든 날, 모든 순간 Every day, Every Moment</a:t>
-                      </a:r>
-                    </a:p>
-                  </a:txBody>
-                  <a:tcPr>
-                    <a:solidFill>
-                      <a:srgbClr val="F0F0F0"/>
-                    </a:solidFill>
-                  </a:tcPr>
-                </a:tc>
-                <a:tc>
-                  <a:txBody>
-                    <a:bodyPr/>
-                    <a:lstStyle/>
-                    <a:p>
-                      <a:r>
-                        <a:rPr sz="800"/>
-                        <a:t>0.960</a:t>
-                      </a:r>
-                    </a:p>
-                  </a:txBody>
-                  <a:tcPr>
-                    <a:solidFill>
-                      <a:srgbClr val="F0F0F0"/>
-                    </a:solidFill>
-                  </a:tcPr>
-                </a:tc>
-                <a:tc>
-                  <a:txBody>
-                    <a:bodyPr/>
-                    <a:lstStyle/>
-                    <a:p>
-                      <a:r>
-                        <a:rPr sz="800"/>
-                        <a:t>1.000</a:t>
-                      </a:r>
-                    </a:p>
-                  </a:txBody>
-                  <a:tcPr>
-                    <a:solidFill>
-                      <a:srgbClr val="F0F0F0"/>
-                    </a:solidFill>
-                  </a:tcPr>
-                </a:tc>
-                <a:tc>
-                  <a:txBody>
-                    <a:bodyPr/>
-                    <a:lstStyle/>
-                    <a:p>
-                      <a:r>
-                        <a:rPr sz="800"/>
-                        <a:t>S</a:t>
-                      </a:r>
-                    </a:p>
-                  </a:txBody>
-                  <a:tcPr>
-                    <a:solidFill>
-                      <a:srgbClr val="F0F0F0"/>
-                    </a:solidFill>
-                  </a:tcPr>
-                </a:tc>
-              </a:tr>
-              <a:tr h="502920">
-                <a:tc>
-                  <a:txBody>
-                    <a:bodyPr/>
-                    <a:lstStyle/>
-                    <a:p>
-                      <a:r>
-                        <a:rPr sz="800"/>
-                        <a:t>12</a:t>
-                      </a:r>
-                    </a:p>
-                  </a:txBody>
-                  <a:tcPr/>
-                </a:tc>
-                <a:tc>
-                  <a:txBody>
-                    <a:bodyPr/>
-                    <a:lstStyle/>
-                    <a:p>
-                      <a:r>
-                        <a:rPr sz="800"/>
-                        <a:t>Let's go see the stars (별 보러 가자)</a:t>
-                      </a:r>
-                    </a:p>
-                  </a:txBody>
-                  <a:tcPr/>
-                </a:tc>
-                <a:tc>
-                  <a:txBody>
-                    <a:bodyPr/>
-                    <a:lstStyle/>
-                    <a:p>
-                      <a:r>
-                        <a:rPr sz="800"/>
-                        <a:t>0.970</a:t>
-                      </a:r>
-                    </a:p>
-                  </a:txBody>
-                  <a:tcPr/>
-                </a:tc>
-                <a:tc>
-                  <a:txBody>
-                    <a:bodyPr/>
-                    <a:lstStyle/>
-                    <a:p>
-                      <a:r>
-                        <a:rPr sz="800"/>
-                        <a:t>0.954</a:t>
-                      </a:r>
-                    </a:p>
-                  </a:txBody>
-                  <a:tcPr/>
-                </a:tc>
-                <a:tc>
-                  <a:txBody>
-                    <a:bodyPr/>
-                    <a:lstStyle/>
-                    <a:p>
-                      <a:r>
-                        <a:rPr sz="800"/>
-                        <a:t>S</a:t>
-                      </a:r>
-                    </a:p>
-                  </a:txBody>
-                  <a:tcPr/>
-                </a:tc>
-              </a:tr>
-              <a:tr h="502920">
-                <a:tc>
-                  <a:txBody>
-                    <a:bodyPr/>
-                    <a:lstStyle/>
-                    <a:p>
-                      <a:r>
-                        <a:rPr sz="800"/>
-                        <a:t>13</a:t>
-                      </a:r>
-                    </a:p>
-                  </a:txBody>
-                  <a:tcPr>
-                    <a:solidFill>
-                      <a:srgbClr val="F0F0F0"/>
-                    </a:solidFill>
-                  </a:tcPr>
-                </a:tc>
-                <a:tc>
-                  <a:txBody>
-                    <a:bodyPr/>
-                    <a:lstStyle/>
-                    <a:p>
-                      <a:r>
-                        <a:rPr sz="800"/>
-                        <a:t>TOMBOY</a:t>
-                      </a:r>
-                    </a:p>
-                  </a:txBody>
-                  <a:tcPr>
-                    <a:solidFill>
-                      <a:srgbClr val="F0F0F0"/>
-                    </a:solidFill>
-                  </a:tcPr>
-                </a:tc>
-                <a:tc>
-                  <a:txBody>
-                    <a:bodyPr/>
-                    <a:lstStyle/>
-                    <a:p>
-                      <a:r>
-                        <a:rPr sz="800"/>
-                        <a:t>0.653</a:t>
-                      </a:r>
-                    </a:p>
-                  </a:txBody>
-                  <a:tcPr>
-                    <a:solidFill>
-                      <a:srgbClr val="F0F0F0"/>
-                    </a:solidFill>
-                  </a:tcPr>
-                </a:tc>
-                <a:tc>
-                  <a:txBody>
-                    <a:bodyPr/>
-                    <a:lstStyle/>
-                    <a:p>
-                      <a:r>
-                        <a:rPr sz="800"/>
-                        <a:t>0.927</a:t>
-                      </a:r>
-                    </a:p>
-                  </a:txBody>
-                  <a:tcPr>
-                    <a:solidFill>
-                      <a:srgbClr val="F0F0F0"/>
-                    </a:solidFill>
-                  </a:tcPr>
-                </a:tc>
-                <a:tc>
-                  <a:txBody>
-                    <a:bodyPr/>
-                    <a:lstStyle/>
-                    <a:p>
-                      <a:r>
-                        <a:rPr sz="800"/>
-                        <a:t>S</a:t>
-                      </a:r>
-                    </a:p>
-                  </a:txBody>
-                  <a:tcPr>
-                    <a:solidFill>
-                      <a:srgbClr val="F0F0F0"/>
-                    </a:solidFill>
-                  </a:tcPr>
-                </a:tc>
-              </a:tr>
-              <a:tr h="502920">
-                <a:tc>
-                  <a:txBody>
-                    <a:bodyPr/>
-                    <a:lstStyle/>
-                    <a:p>
-                      <a:r>
-                        <a:rPr sz="800"/>
-                        <a:t>14</a:t>
-                      </a:r>
-                    </a:p>
-                  </a:txBody>
-                  <a:tcPr/>
-                </a:tc>
-                <a:tc>
-                  <a:txBody>
-                    <a:bodyPr/>
-                    <a:lstStyle/>
-                    <a:p>
-                      <a:r>
-                        <a:rPr sz="800"/>
-                        <a:t>iKON - '사랑을 했다(LOVE SCENARIO)' MV</a:t>
-                      </a:r>
-                    </a:p>
-                  </a:txBody>
-                  <a:tcPr/>
-                </a:tc>
-                <a:tc>
-                  <a:txBody>
-                    <a:bodyPr/>
-                    <a:lstStyle/>
-                    <a:p>
-                      <a:r>
-                        <a:rPr sz="800"/>
-                        <a:t>0.937</a:t>
-                      </a:r>
-                    </a:p>
-                  </a:txBody>
-                  <a:tcPr/>
-                </a:tc>
-                <a:tc>
-                  <a:txBody>
-                    <a:bodyPr/>
-                    <a:lstStyle/>
-                    <a:p>
-                      <a:r>
-                        <a:rPr sz="800"/>
-                        <a:t>0.989</a:t>
-                      </a:r>
-                    </a:p>
-                  </a:txBody>
-                  <a:tcPr/>
-                </a:tc>
-                <a:tc>
-                  <a:txBody>
-                    <a:bodyPr/>
-                    <a:lstStyle/>
-                    <a:p>
-                      <a:r>
-                        <a:rPr sz="800"/>
-                        <a:t>S</a:t>
-                      </a:r>
-                    </a:p>
-                  </a:txBody>
-                  <a:tcPr/>
-                </a:tc>
-              </a:tr>
-              <a:tr h="502920">
-                <a:tc>
-                  <a:txBody>
-                    <a:bodyPr/>
-                    <a:lstStyle/>
-                    <a:p>
-                      <a:r>
-                        <a:rPr sz="800"/>
-                        <a:t>15</a:t>
-                      </a:r>
-                    </a:p>
-                  </a:txBody>
-                  <a:tcPr>
-                    <a:solidFill>
-                      <a:srgbClr val="F0F0F0"/>
-                    </a:solidFill>
-                  </a:tcPr>
-                </a:tc>
-                <a:tc>
-                  <a:txBody>
-                    <a:bodyPr/>
-                    <a:lstStyle/>
-                    <a:p>
-                      <a:r>
-                        <a:rPr sz="800"/>
-                        <a:t>BLACKPINK - 'Kill This Love' MV</a:t>
-                      </a:r>
-                    </a:p>
-                  </a:txBody>
-                  <a:tcPr>
-                    <a:solidFill>
-                      <a:srgbClr val="F0F0F0"/>
-                    </a:solidFill>
-                  </a:tcPr>
-                </a:tc>
-                <a:tc>
-                  <a:txBody>
-                    <a:bodyPr/>
-                    <a:lstStyle/>
-                    <a:p>
-                      <a:r>
-                        <a:rPr sz="800"/>
-                        <a:t>0.979</a:t>
-                      </a:r>
-                    </a:p>
-                  </a:txBody>
-                  <a:tcPr>
-                    <a:solidFill>
-                      <a:srgbClr val="F0F0F0"/>
-                    </a:solidFill>
-                  </a:tcPr>
-                </a:tc>
-                <a:tc>
-                  <a:txBody>
-                    <a:bodyPr/>
-                    <a:lstStyle/>
-                    <a:p>
-                      <a:r>
-                        <a:rPr sz="800"/>
-                        <a:t>0.979</a:t>
-                      </a:r>
-                    </a:p>
-                  </a:txBody>
-                  <a:tcPr>
-                    <a:solidFill>
-                      <a:srgbClr val="F0F0F0"/>
-                    </a:solidFill>
-                  </a:tcPr>
-                </a:tc>
-                <a:tc>
-                  <a:txBody>
-                    <a:bodyPr/>
-                    <a:lstStyle/>
-                    <a:p>
-                      <a:r>
-                        <a:rPr sz="800"/>
-                        <a:t>S</a:t>
-                      </a:r>
-                    </a:p>
-                  </a:txBody>
-                  <a:tcPr>
-                    <a:solidFill>
-                      <a:srgbClr val="F0F0F0"/>
-                    </a:solidFill>
-                  </a:tcPr>
-                </a:tc>
-              </a:tr>
-              <a:tr h="502920">
-                <a:tc>
-                  <a:txBody>
-                    <a:bodyPr/>
-                    <a:lstStyle/>
-                    <a:p>
-                      <a:r>
-                        <a:rPr sz="800"/>
-                        <a:t>16</a:t>
-                      </a:r>
-                    </a:p>
-                  </a:txBody>
-                  <a:tcPr/>
-                </a:tc>
-                <a:tc>
-                  <a:txBody>
-                    <a:bodyPr/>
-                    <a:lstStyle/>
-                    <a:p>
-                      <a:r>
-                        <a:rPr sz="800"/>
-                        <a:t>Celebrity (Celebrity)</a:t>
-                      </a:r>
-                    </a:p>
-                  </a:txBody>
-                  <a:tcPr/>
-                </a:tc>
-                <a:tc>
-                  <a:txBody>
-                    <a:bodyPr/>
-                    <a:lstStyle/>
-                    <a:p>
-                      <a:r>
-                        <a:rPr sz="800"/>
-                        <a:t>0.995</a:t>
-                      </a:r>
-                    </a:p>
-                  </a:txBody>
-                  <a:tcPr/>
-                </a:tc>
-                <a:tc>
-                  <a:txBody>
-                    <a:bodyPr/>
-                    <a:lstStyle/>
-                    <a:p>
-                      <a:r>
-                        <a:rPr sz="800"/>
-                        <a:t>0.595</a:t>
-                      </a:r>
-                    </a:p>
-                  </a:txBody>
-                  <a:tcPr/>
-                </a:tc>
-                <a:tc>
-                  <a:txBody>
-                    <a:bodyPr/>
-                    <a:lstStyle/>
-                    <a:p>
-                      <a:r>
-                        <a:rPr sz="800"/>
-                        <a:t>C</a:t>
-                      </a:r>
-                    </a:p>
-                  </a:txBody>
-                  <a:tcPr/>
-                </a:tc>
-              </a:tr>
-              <a:tr h="502920">
-                <a:tc>
-                  <a:txBody>
-                    <a:bodyPr/>
-                    <a:lstStyle/>
-                    <a:p>
-                      <a:r>
-                        <a:rPr sz="800"/>
-                        <a:t>17</a:t>
-                      </a:r>
-                    </a:p>
-                  </a:txBody>
-                  <a:tcPr>
-                    <a:solidFill>
-                      <a:srgbClr val="F0F0F0"/>
-                    </a:solidFill>
-                  </a:tcPr>
-                </a:tc>
-                <a:tc>
-                  <a:txBody>
-                    <a:bodyPr/>
-                    <a:lstStyle/>
-                    <a:p>
-                      <a:r>
-                        <a:rPr sz="800"/>
-                        <a:t>Pimple</a:t>
-                      </a:r>
-                    </a:p>
-                  </a:txBody>
-                  <a:tcPr>
-                    <a:solidFill>
-                      <a:srgbClr val="F0F0F0"/>
-                    </a:solidFill>
-                  </a:tcPr>
-                </a:tc>
-                <a:tc>
-                  <a:txBody>
-                    <a:bodyPr/>
-                    <a:lstStyle/>
-                    <a:p>
-                      <a:r>
-                        <a:rPr sz="800"/>
-                        <a:t>0.618</a:t>
-                      </a:r>
-                    </a:p>
-                  </a:txBody>
-                  <a:tcPr>
-                    <a:solidFill>
-                      <a:srgbClr val="F0F0F0"/>
-                    </a:solidFill>
-                  </a:tcPr>
-                </a:tc>
-                <a:tc>
-                  <a:txBody>
-                    <a:bodyPr/>
-                    <a:lstStyle/>
-                    <a:p>
-                      <a:r>
-                        <a:rPr sz="800"/>
-                        <a:t>0.984</a:t>
-                      </a:r>
-                    </a:p>
-                  </a:txBody>
-                  <a:tcPr>
-                    <a:solidFill>
-                      <a:srgbClr val="F0F0F0"/>
-                    </a:solidFill>
-                  </a:tcPr>
-                </a:tc>
-                <a:tc>
-                  <a:txBody>
-                    <a:bodyPr/>
-                    <a:lstStyle/>
-                    <a:p>
-                      <a:r>
-                        <a:rPr sz="800"/>
-                        <a:t>S</a:t>
-                      </a:r>
-                    </a:p>
-                  </a:txBody>
-                  <a:tcPr>
-                    <a:solidFill>
-                      <a:srgbClr val="F0F0F0"/>
-                    </a:solidFill>
-                  </a:tcPr>
-                </a:tc>
-              </a:tr>
-              <a:tr h="502920">
-                <a:tc>
-                  <a:txBody>
-                    <a:bodyPr/>
-                    <a:lstStyle/>
-                    <a:p>
-                      <a:r>
-                        <a:rPr sz="800"/>
-                        <a:t>18</a:t>
-                      </a:r>
-                    </a:p>
-                  </a:txBody>
-                  <a:tcPr/>
-                </a:tc>
-                <a:tc>
-                  <a:txBody>
-                    <a:bodyPr/>
-                    <a:lstStyle/>
-                    <a:p>
-                      <a:r>
-                        <a:rPr sz="800"/>
-                        <a:t>Tick-Tack</a:t>
-                      </a:r>
-                    </a:p>
-                  </a:txBody>
-                  <a:tcPr/>
-                </a:tc>
-                <a:tc>
-                  <a:txBody>
-                    <a:bodyPr/>
-                    <a:lstStyle/>
-                    <a:p>
-                      <a:r>
-                        <a:rPr sz="800"/>
-                        <a:t>0.953</a:t>
-                      </a:r>
-                    </a:p>
-                  </a:txBody>
-                  <a:tcPr/>
-                </a:tc>
-                <a:tc>
-                  <a:txBody>
-                    <a:bodyPr/>
-                    <a:lstStyle/>
-                    <a:p>
-                      <a:r>
-                        <a:rPr sz="800"/>
-                        <a:t>0.988</a:t>
-                      </a:r>
-                    </a:p>
-                  </a:txBody>
-                  <a:tcPr/>
-                </a:tc>
-                <a:tc>
-                  <a:txBody>
-                    <a:bodyPr/>
-                    <a:lstStyle/>
-                    <a:p>
-                      <a:r>
-                        <a:rPr sz="800"/>
+                        <a:rPr sz="850"/>
+                        <a:t>Soda Pop Official Lyric Video KPop ..</a:t>
+                      </a:r>
+                    </a:p>
+                  </a:txBody>
+                  <a:tcPr/>
+                </a:tc>
+                <a:tc>
+                  <a:txBody>
+                    <a:bodyPr/>
+                    <a:lstStyle/>
+                    <a:p>
+                      <a:r>
+                        <a:rPr sz="850"/>
+                        <a:t>0.994</a:t>
+                      </a:r>
+                    </a:p>
+                  </a:txBody>
+                  <a:tcPr/>
+                </a:tc>
+                <a:tc>
+                  <a:txBody>
+                    <a:bodyPr/>
+                    <a:lstStyle/>
+                    <a:p>
+                      <a:r>
+                        <a:rPr sz="850"/>
+                        <a:t>0.968</a:t>
+                      </a:r>
+                    </a:p>
+                  </a:txBody>
+                  <a:tcPr/>
+                </a:tc>
+                <a:tc>
+                  <a:txBody>
+                    <a:bodyPr/>
+                    <a:lstStyle/>
+                    <a:p>
+                      <a:r>
+                        <a:rPr sz="850"/>
                         <a:t>S</a:t>
                       </a:r>
                     </a:p>
@@ -6017,7 +5322,7 @@
               </a:defRPr>
             </a:pPr>
             <a:r>
-              <a:t>🎵 POP 곡 분석</a:t>
+              <a:t>🎵 K-POP - Pop 곡 분석</a:t>
             </a:r>
           </a:p>
         </p:txBody>
@@ -6052,7 +5357,7 @@
               </a:defRPr>
             </a:pPr>
             <a:r>
-              <a:t>POP: 8곡 (madmom 기준)</a:t>
+              <a:t>K-POP - Pop: 8곡 (madmom 기준)</a:t>
             </a:r>
           </a:p>
         </p:txBody>
@@ -6210,20 +5515,20 @@
                     <a:p>
                       <a:r>
                         <a:rPr sz="850"/>
-                        <a:t>Charlie Puth - Attention [Official ..</a:t>
-                      </a:r>
-                    </a:p>
-                  </a:txBody>
-                  <a:tcPr/>
-                </a:tc>
-                <a:tc>
-                  <a:txBody>
-                    <a:bodyPr/>
-                    <a:lstStyle/>
-                    <a:p>
-                      <a:r>
-                        <a:rPr sz="850"/>
-                        <a:t>0.922</a:t>
+                        <a:t>ILLIT (아일릿) 'Lucky Girl Syndrome' O..</a:t>
+                      </a:r>
+                    </a:p>
+                  </a:txBody>
+                  <a:tcPr/>
+                </a:tc>
+                <a:tc>
+                  <a:txBody>
+                    <a:bodyPr/>
+                    <a:lstStyle/>
+                    <a:p>
+                      <a:r>
+                        <a:rPr sz="850"/>
+                        <a:t>0.967</a:t>
                       </a:r>
                     </a:p>
                   </a:txBody>
@@ -6281,41 +5586,41 @@
                     <a:p>
                       <a:r>
                         <a:rPr sz="850"/>
-                        <a:t>Good Goodbye</a:t>
-                      </a:r>
-                    </a:p>
-                  </a:txBody>
-                  <a:tcPr>
-                    <a:solidFill>
-                      <a:srgbClr val="F0F0F0"/>
-                    </a:solidFill>
-                  </a:tcPr>
-                </a:tc>
-                <a:tc>
-                  <a:txBody>
-                    <a:bodyPr/>
-                    <a:lstStyle/>
-                    <a:p>
-                      <a:r>
-                        <a:rPr sz="850"/>
-                        <a:t>0.870</a:t>
-                      </a:r>
-                    </a:p>
-                  </a:txBody>
-                  <a:tcPr>
-                    <a:solidFill>
-                      <a:srgbClr val="F0F0F0"/>
-                    </a:solidFill>
-                  </a:tcPr>
-                </a:tc>
-                <a:tc>
-                  <a:txBody>
-                    <a:bodyPr/>
-                    <a:lstStyle/>
-                    <a:p>
-                      <a:r>
-                        <a:rPr sz="850"/>
-                        <a:t>0.971</a:t>
+                        <a:t>Almond Chocolate</a:t>
+                      </a:r>
+                    </a:p>
+                  </a:txBody>
+                  <a:tcPr>
+                    <a:solidFill>
+                      <a:srgbClr val="F0F0F0"/>
+                    </a:solidFill>
+                  </a:tcPr>
+                </a:tc>
+                <a:tc>
+                  <a:txBody>
+                    <a:bodyPr/>
+                    <a:lstStyle/>
+                    <a:p>
+                      <a:r>
+                        <a:rPr sz="850"/>
+                        <a:t>0.981</a:t>
+                      </a:r>
+                    </a:p>
+                  </a:txBody>
+                  <a:tcPr>
+                    <a:solidFill>
+                      <a:srgbClr val="F0F0F0"/>
+                    </a:solidFill>
+                  </a:tcPr>
+                </a:tc>
+                <a:tc>
+                  <a:txBody>
+                    <a:bodyPr/>
+                    <a:lstStyle/>
+                    <a:p>
+                      <a:r>
+                        <a:rPr sz="850"/>
+                        <a:t>0.999</a:t>
                       </a:r>
                     </a:p>
                   </a:txBody>
@@ -6364,33 +5669,33 @@
                     <a:p>
                       <a:r>
                         <a:rPr sz="850"/>
-                        <a:t>I'll Like You</a:t>
-                      </a:r>
-                    </a:p>
-                  </a:txBody>
-                  <a:tcPr/>
-                </a:tc>
-                <a:tc>
-                  <a:txBody>
-                    <a:bodyPr/>
-                    <a:lstStyle/>
-                    <a:p>
-                      <a:r>
-                        <a:rPr sz="850"/>
-                        <a:t>0.977</a:t>
-                      </a:r>
-                    </a:p>
-                  </a:txBody>
-                  <a:tcPr/>
-                </a:tc>
-                <a:tc>
-                  <a:txBody>
-                    <a:bodyPr/>
-                    <a:lstStyle/>
-                    <a:p>
-                      <a:r>
-                        <a:rPr sz="850"/>
-                        <a:t>0.993</a:t>
+                        <a:t>IYKYK (If You Know You Know)</a:t>
+                      </a:r>
+                    </a:p>
+                  </a:txBody>
+                  <a:tcPr/>
+                </a:tc>
+                <a:tc>
+                  <a:txBody>
+                    <a:bodyPr/>
+                    <a:lstStyle/>
+                    <a:p>
+                      <a:r>
+                        <a:rPr sz="850"/>
+                        <a:t>0.883</a:t>
+                      </a:r>
+                    </a:p>
+                  </a:txBody>
+                  <a:tcPr/>
+                </a:tc>
+                <a:tc>
+                  <a:txBody>
+                    <a:bodyPr/>
+                    <a:lstStyle/>
+                    <a:p>
+                      <a:r>
+                        <a:rPr sz="850"/>
+                        <a:t>0.998</a:t>
                       </a:r>
                     </a:p>
                   </a:txBody>
@@ -6435,58 +5740,58 @@
                     <a:p>
                       <a:r>
                         <a:rPr sz="850"/>
-                        <a:t>My World</a:t>
-                      </a:r>
-                    </a:p>
-                  </a:txBody>
-                  <a:tcPr>
-                    <a:solidFill>
-                      <a:srgbClr val="F0F0F0"/>
-                    </a:solidFill>
-                  </a:tcPr>
-                </a:tc>
-                <a:tc>
-                  <a:txBody>
-                    <a:bodyPr/>
-                    <a:lstStyle/>
-                    <a:p>
-                      <a:r>
-                        <a:rPr sz="850"/>
-                        <a:t>0.971</a:t>
-                      </a:r>
-                    </a:p>
-                  </a:txBody>
-                  <a:tcPr>
-                    <a:solidFill>
-                      <a:srgbClr val="F0F0F0"/>
-                    </a:solidFill>
-                  </a:tcPr>
-                </a:tc>
-                <a:tc>
-                  <a:txBody>
-                    <a:bodyPr/>
-                    <a:lstStyle/>
-                    <a:p>
-                      <a:r>
-                        <a:rPr sz="850"/>
-                        <a:t>0.974</a:t>
-                      </a:r>
-                    </a:p>
-                  </a:txBody>
-                  <a:tcPr>
-                    <a:solidFill>
-                      <a:srgbClr val="F0F0F0"/>
-                    </a:solidFill>
-                  </a:tcPr>
-                </a:tc>
-                <a:tc>
-                  <a:txBody>
-                    <a:bodyPr/>
-                    <a:lstStyle/>
-                    <a:p>
-                      <a:r>
-                        <a:rPr sz="850"/>
-                        <a:t>S</a:t>
+                        <a:t>Celebrity (Celebrity)</a:t>
+                      </a:r>
+                    </a:p>
+                  </a:txBody>
+                  <a:tcPr>
+                    <a:solidFill>
+                      <a:srgbClr val="F0F0F0"/>
+                    </a:solidFill>
+                  </a:tcPr>
+                </a:tc>
+                <a:tc>
+                  <a:txBody>
+                    <a:bodyPr/>
+                    <a:lstStyle/>
+                    <a:p>
+                      <a:r>
+                        <a:rPr sz="850"/>
+                        <a:t>0.995</a:t>
+                      </a:r>
+                    </a:p>
+                  </a:txBody>
+                  <a:tcPr>
+                    <a:solidFill>
+                      <a:srgbClr val="F0F0F0"/>
+                    </a:solidFill>
+                  </a:tcPr>
+                </a:tc>
+                <a:tc>
+                  <a:txBody>
+                    <a:bodyPr/>
+                    <a:lstStyle/>
+                    <a:p>
+                      <a:r>
+                        <a:rPr sz="850"/>
+                        <a:t>0.595</a:t>
+                      </a:r>
+                    </a:p>
+                  </a:txBody>
+                  <a:tcPr>
+                    <a:solidFill>
+                      <a:srgbClr val="F0F0F0"/>
+                    </a:solidFill>
+                  </a:tcPr>
+                </a:tc>
+                <a:tc>
+                  <a:txBody>
+                    <a:bodyPr/>
+                    <a:lstStyle/>
+                    <a:p>
+                      <a:r>
+                        <a:rPr sz="850"/>
+                        <a:t>C</a:t>
                       </a:r>
                     </a:p>
                   </a:txBody>
@@ -6518,33 +5823,33 @@
                     <a:p>
                       <a:r>
                         <a:rPr sz="850"/>
-                        <a:t>Attention</a:t>
-                      </a:r>
-                    </a:p>
-                  </a:txBody>
-                  <a:tcPr/>
-                </a:tc>
-                <a:tc>
-                  <a:txBody>
-                    <a:bodyPr/>
-                    <a:lstStyle/>
-                    <a:p>
-                      <a:r>
-                        <a:rPr sz="850"/>
-                        <a:t>0.921</a:t>
-                      </a:r>
-                    </a:p>
-                  </a:txBody>
-                  <a:tcPr/>
-                </a:tc>
-                <a:tc>
-                  <a:txBody>
-                    <a:bodyPr/>
-                    <a:lstStyle/>
-                    <a:p>
-                      <a:r>
-                        <a:rPr sz="850"/>
-                        <a:t>0.915</a:t>
+                        <a:t>Pimple</a:t>
+                      </a:r>
+                    </a:p>
+                  </a:txBody>
+                  <a:tcPr/>
+                </a:tc>
+                <a:tc>
+                  <a:txBody>
+                    <a:bodyPr/>
+                    <a:lstStyle/>
+                    <a:p>
+                      <a:r>
+                        <a:rPr sz="850"/>
+                        <a:t>0.618</a:t>
+                      </a:r>
+                    </a:p>
+                  </a:txBody>
+                  <a:tcPr/>
+                </a:tc>
+                <a:tc>
+                  <a:txBody>
+                    <a:bodyPr/>
+                    <a:lstStyle/>
+                    <a:p>
+                      <a:r>
+                        <a:rPr sz="850"/>
+                        <a:t>0.984</a:t>
                       </a:r>
                     </a:p>
                   </a:txBody>
@@ -6589,58 +5894,58 @@
                     <a:p>
                       <a:r>
                         <a:rPr sz="850"/>
-                        <a:t>Golden</a:t>
-                      </a:r>
-                    </a:p>
-                  </a:txBody>
-                  <a:tcPr>
-                    <a:solidFill>
-                      <a:srgbClr val="F0F0F0"/>
-                    </a:solidFill>
-                  </a:tcPr>
-                </a:tc>
-                <a:tc>
-                  <a:txBody>
-                    <a:bodyPr/>
-                    <a:lstStyle/>
-                    <a:p>
-                      <a:r>
-                        <a:rPr sz="850"/>
-                        <a:t>0.695</a:t>
-                      </a:r>
-                    </a:p>
-                  </a:txBody>
-                  <a:tcPr>
-                    <a:solidFill>
-                      <a:srgbClr val="F0F0F0"/>
-                    </a:solidFill>
-                  </a:tcPr>
-                </a:tc>
-                <a:tc>
-                  <a:txBody>
-                    <a:bodyPr/>
-                    <a:lstStyle/>
-                    <a:p>
-                      <a:r>
-                        <a:rPr sz="850"/>
-                        <a:t>0.775</a:t>
-                      </a:r>
-                    </a:p>
-                  </a:txBody>
-                  <a:tcPr>
-                    <a:solidFill>
-                      <a:srgbClr val="F0F0F0"/>
-                    </a:solidFill>
-                  </a:tcPr>
-                </a:tc>
-                <a:tc>
-                  <a:txBody>
-                    <a:bodyPr/>
-                    <a:lstStyle/>
-                    <a:p>
-                      <a:r>
-                        <a:rPr sz="850"/>
-                        <a:t>A</a:t>
+                        <a:t>Tick-Tack</a:t>
+                      </a:r>
+                    </a:p>
+                  </a:txBody>
+                  <a:tcPr>
+                    <a:solidFill>
+                      <a:srgbClr val="F0F0F0"/>
+                    </a:solidFill>
+                  </a:tcPr>
+                </a:tc>
+                <a:tc>
+                  <a:txBody>
+                    <a:bodyPr/>
+                    <a:lstStyle/>
+                    <a:p>
+                      <a:r>
+                        <a:rPr sz="850"/>
+                        <a:t>0.953</a:t>
+                      </a:r>
+                    </a:p>
+                  </a:txBody>
+                  <a:tcPr>
+                    <a:solidFill>
+                      <a:srgbClr val="F0F0F0"/>
+                    </a:solidFill>
+                  </a:tcPr>
+                </a:tc>
+                <a:tc>
+                  <a:txBody>
+                    <a:bodyPr/>
+                    <a:lstStyle/>
+                    <a:p>
+                      <a:r>
+                        <a:rPr sz="850"/>
+                        <a:t>0.988</a:t>
+                      </a:r>
+                    </a:p>
+                  </a:txBody>
+                  <a:tcPr>
+                    <a:solidFill>
+                      <a:srgbClr val="F0F0F0"/>
+                    </a:solidFill>
+                  </a:tcPr>
+                </a:tc>
+                <a:tc>
+                  <a:txBody>
+                    <a:bodyPr/>
+                    <a:lstStyle/>
+                    <a:p>
+                      <a:r>
+                        <a:rPr sz="850"/>
+                        <a:t>S</a:t>
                       </a:r>
                     </a:p>
                   </a:txBody>
@@ -6672,33 +5977,33 @@
                     <a:p>
                       <a:r>
                         <a:rPr sz="850"/>
-                        <a:t>Ed Sheeran - Shape of You (Official..</a:t>
-                      </a:r>
-                    </a:p>
-                  </a:txBody>
-                  <a:tcPr/>
-                </a:tc>
-                <a:tc>
-                  <a:txBody>
-                    <a:bodyPr/>
-                    <a:lstStyle/>
-                    <a:p>
-                      <a:r>
-                        <a:rPr sz="850"/>
-                        <a:t>0.253</a:t>
-                      </a:r>
-                    </a:p>
-                  </a:txBody>
-                  <a:tcPr/>
-                </a:tc>
-                <a:tc>
-                  <a:txBody>
-                    <a:bodyPr/>
-                    <a:lstStyle/>
-                    <a:p>
-                      <a:r>
-                        <a:rPr sz="850"/>
-                        <a:t>0.577</a:t>
+                        <a:t>Magnetic</a:t>
+                      </a:r>
+                    </a:p>
+                  </a:txBody>
+                  <a:tcPr/>
+                </a:tc>
+                <a:tc>
+                  <a:txBody>
+                    <a:bodyPr/>
+                    <a:lstStyle/>
+                    <a:p>
+                      <a:r>
+                        <a:rPr sz="850"/>
+                        <a:t>0.976</a:t>
+                      </a:r>
+                    </a:p>
+                  </a:txBody>
+                  <a:tcPr/>
+                </a:tc>
+                <a:tc>
+                  <a:txBody>
+                    <a:bodyPr/>
+                    <a:lstStyle/>
+                    <a:p>
+                      <a:r>
+                        <a:rPr sz="850"/>
+                        <a:t>0.525</a:t>
                       </a:r>
                     </a:p>
                   </a:txBody>
@@ -6743,41 +6048,41 @@
                     <a:p>
                       <a:r>
                         <a:rPr sz="850"/>
-                        <a:t>Dynamite</a:t>
-                      </a:r>
-                    </a:p>
-                  </a:txBody>
-                  <a:tcPr>
-                    <a:solidFill>
-                      <a:srgbClr val="F0F0F0"/>
-                    </a:solidFill>
-                  </a:tcPr>
-                </a:tc>
-                <a:tc>
-                  <a:txBody>
-                    <a:bodyPr/>
-                    <a:lstStyle/>
-                    <a:p>
-                      <a:r>
-                        <a:rPr sz="850"/>
-                        <a:t>0.895</a:t>
-                      </a:r>
-                    </a:p>
-                  </a:txBody>
-                  <a:tcPr>
-                    <a:solidFill>
-                      <a:srgbClr val="F0F0F0"/>
-                    </a:solidFill>
-                  </a:tcPr>
-                </a:tc>
-                <a:tc>
-                  <a:txBody>
-                    <a:bodyPr/>
-                    <a:lstStyle/>
-                    <a:p>
-                      <a:r>
-                        <a:rPr sz="850"/>
-                        <a:t>0.988</a:t>
+                        <a:t>Good Goodbye</a:t>
+                      </a:r>
+                    </a:p>
+                  </a:txBody>
+                  <a:tcPr>
+                    <a:solidFill>
+                      <a:srgbClr val="F0F0F0"/>
+                    </a:solidFill>
+                  </a:tcPr>
+                </a:tc>
+                <a:tc>
+                  <a:txBody>
+                    <a:bodyPr/>
+                    <a:lstStyle/>
+                    <a:p>
+                      <a:r>
+                        <a:rPr sz="850"/>
+                        <a:t>0.870</a:t>
+                      </a:r>
+                    </a:p>
+                  </a:txBody>
+                  <a:tcPr>
+                    <a:solidFill>
+                      <a:srgbClr val="F0F0F0"/>
+                    </a:solidFill>
+                  </a:tcPr>
+                </a:tc>
+                <a:tc>
+                  <a:txBody>
+                    <a:bodyPr/>
+                    <a:lstStyle/>
+                    <a:p>
+                      <a:r>
+                        <a:rPr sz="850"/>
+                        <a:t>0.971</a:t>
                       </a:r>
                     </a:p>
                   </a:txBody>
@@ -6882,7 +6187,7 @@
               </a:defRPr>
             </a:pPr>
             <a:r>
-              <a:t>🎵 Others (기타) 곡 분석</a:t>
+              <a:t>🎵 K-POP - Ballad 곡 분석</a:t>
             </a:r>
           </a:p>
         </p:txBody>
@@ -6917,7 +6222,7 @@
               </a:defRPr>
             </a:pPr>
             <a:r>
-              <a:t>Others (기타): 6곡 (madmom 기준)</a:t>
+              <a:t>K-POP - Ballad: 7곡 (madmom 기준)</a:t>
             </a:r>
           </a:p>
         </p:txBody>
@@ -6947,7 +6252,7 @@
                 <a:gridCol w="1719072"/>
                 <a:gridCol w="1719072"/>
               </a:tblGrid>
-              <a:tr h="718457">
+              <a:tr h="628650">
                 <a:tc>
                   <a:txBody>
                     <a:bodyPr/>
@@ -7054,7 +6359,7 @@
                   </a:tcPr>
                 </a:tc>
               </a:tr>
-              <a:tr h="718457">
+              <a:tr h="628650">
                 <a:tc>
                   <a:txBody>
                     <a:bodyPr/>
@@ -7075,33 +6380,187 @@
                     <a:p>
                       <a:r>
                         <a:rPr sz="850"/>
-                        <a:t>aespa 에스파 'Next Level' MV</a:t>
-                      </a:r>
-                    </a:p>
-                  </a:txBody>
-                  <a:tcPr/>
-                </a:tc>
-                <a:tc>
-                  <a:txBody>
-                    <a:bodyPr/>
-                    <a:lstStyle/>
-                    <a:p>
-                      <a:r>
-                        <a:rPr sz="850"/>
-                        <a:t>0.801</a:t>
-                      </a:r>
-                    </a:p>
-                  </a:txBody>
-                  <a:tcPr/>
-                </a:tc>
-                <a:tc>
-                  <a:txBody>
-                    <a:bodyPr/>
-                    <a:lstStyle/>
-                    <a:p>
-                      <a:r>
-                        <a:rPr sz="850"/>
-                        <a:t>0.840</a:t>
+                        <a:t>ILLIT (아일릿) 'Cherish (My Love)' Dan..</a:t>
+                      </a:r>
+                    </a:p>
+                  </a:txBody>
+                  <a:tcPr/>
+                </a:tc>
+                <a:tc>
+                  <a:txBody>
+                    <a:bodyPr/>
+                    <a:lstStyle/>
+                    <a:p>
+                      <a:r>
+                        <a:rPr sz="850"/>
+                        <a:t>0.684</a:t>
+                      </a:r>
+                    </a:p>
+                  </a:txBody>
+                  <a:tcPr/>
+                </a:tc>
+                <a:tc>
+                  <a:txBody>
+                    <a:bodyPr/>
+                    <a:lstStyle/>
+                    <a:p>
+                      <a:r>
+                        <a:rPr sz="850"/>
+                        <a:t>0.668</a:t>
+                      </a:r>
+                    </a:p>
+                  </a:txBody>
+                  <a:tcPr/>
+                </a:tc>
+                <a:tc>
+                  <a:txBody>
+                    <a:bodyPr/>
+                    <a:lstStyle/>
+                    <a:p>
+                      <a:r>
+                        <a:rPr sz="850"/>
+                        <a:t>B</a:t>
+                      </a:r>
+                    </a:p>
+                  </a:txBody>
+                  <a:tcPr/>
+                </a:tc>
+              </a:tr>
+              <a:tr h="628650">
+                <a:tc>
+                  <a:txBody>
+                    <a:bodyPr/>
+                    <a:lstStyle/>
+                    <a:p>
+                      <a:r>
+                        <a:rPr sz="850"/>
+                        <a:t>2</a:t>
+                      </a:r>
+                    </a:p>
+                  </a:txBody>
+                  <a:tcPr>
+                    <a:solidFill>
+                      <a:srgbClr val="F0F0F0"/>
+                    </a:solidFill>
+                  </a:tcPr>
+                </a:tc>
+                <a:tc>
+                  <a:txBody>
+                    <a:bodyPr/>
+                    <a:lstStyle/>
+                    <a:p>
+                      <a:r>
+                        <a:rPr sz="850"/>
+                        <a:t>02_Magnetic_ILLIT</a:t>
+                      </a:r>
+                    </a:p>
+                  </a:txBody>
+                  <a:tcPr>
+                    <a:solidFill>
+                      <a:srgbClr val="F0F0F0"/>
+                    </a:solidFill>
+                  </a:tcPr>
+                </a:tc>
+                <a:tc>
+                  <a:txBody>
+                    <a:bodyPr/>
+                    <a:lstStyle/>
+                    <a:p>
+                      <a:r>
+                        <a:rPr sz="850"/>
+                        <a:t>0.470</a:t>
+                      </a:r>
+                    </a:p>
+                  </a:txBody>
+                  <a:tcPr>
+                    <a:solidFill>
+                      <a:srgbClr val="F0F0F0"/>
+                    </a:solidFill>
+                  </a:tcPr>
+                </a:tc>
+                <a:tc>
+                  <a:txBody>
+                    <a:bodyPr/>
+                    <a:lstStyle/>
+                    <a:p>
+                      <a:r>
+                        <a:rPr sz="850"/>
+                        <a:t>0.739</a:t>
+                      </a:r>
+                    </a:p>
+                  </a:txBody>
+                  <a:tcPr>
+                    <a:solidFill>
+                      <a:srgbClr val="F0F0F0"/>
+                    </a:solidFill>
+                  </a:tcPr>
+                </a:tc>
+                <a:tc>
+                  <a:txBody>
+                    <a:bodyPr/>
+                    <a:lstStyle/>
+                    <a:p>
+                      <a:r>
+                        <a:rPr sz="850"/>
+                        <a:t>A</a:t>
+                      </a:r>
+                    </a:p>
+                  </a:txBody>
+                  <a:tcPr>
+                    <a:solidFill>
+                      <a:srgbClr val="F0F0F0"/>
+                    </a:solidFill>
+                  </a:tcPr>
+                </a:tc>
+              </a:tr>
+              <a:tr h="628650">
+                <a:tc>
+                  <a:txBody>
+                    <a:bodyPr/>
+                    <a:lstStyle/>
+                    <a:p>
+                      <a:r>
+                        <a:rPr sz="850"/>
+                        <a:t>3</a:t>
+                      </a:r>
+                    </a:p>
+                  </a:txBody>
+                  <a:tcPr/>
+                </a:tc>
+                <a:tc>
+                  <a:txBody>
+                    <a:bodyPr/>
+                    <a:lstStyle/>
+                    <a:p>
+                      <a:r>
+                        <a:rPr sz="850"/>
+                        <a:t>모든 날, 모든 순간 Every day, Every Moment</a:t>
+                      </a:r>
+                    </a:p>
+                  </a:txBody>
+                  <a:tcPr/>
+                </a:tc>
+                <a:tc>
+                  <a:txBody>
+                    <a:bodyPr/>
+                    <a:lstStyle/>
+                    <a:p>
+                      <a:r>
+                        <a:rPr sz="850"/>
+                        <a:t>0.960</a:t>
+                      </a:r>
+                    </a:p>
+                  </a:txBody>
+                  <a:tcPr/>
+                </a:tc>
+                <a:tc>
+                  <a:txBody>
+                    <a:bodyPr/>
+                    <a:lstStyle/>
+                    <a:p>
+                      <a:r>
+                        <a:rPr sz="850"/>
+                        <a:t>1.000</a:t>
                       </a:r>
                     </a:p>
                   </a:txBody>
@@ -7121,83 +6580,83 @@
                   <a:tcPr/>
                 </a:tc>
               </a:tr>
-              <a:tr h="718457">
-                <a:tc>
-                  <a:txBody>
-                    <a:bodyPr/>
-                    <a:lstStyle/>
-                    <a:p>
-                      <a:r>
-                        <a:rPr sz="850"/>
-                        <a:t>2</a:t>
-                      </a:r>
-                    </a:p>
-                  </a:txBody>
-                  <a:tcPr>
-                    <a:solidFill>
-                      <a:srgbClr val="F0F0F0"/>
-                    </a:solidFill>
-                  </a:tcPr>
-                </a:tc>
-                <a:tc>
-                  <a:txBody>
-                    <a:bodyPr/>
-                    <a:lstStyle/>
-                    <a:p>
-                      <a:r>
-                        <a:rPr sz="850"/>
-                        <a:t>Magnetic</a:t>
-                      </a:r>
-                    </a:p>
-                  </a:txBody>
-                  <a:tcPr>
-                    <a:solidFill>
-                      <a:srgbClr val="F0F0F0"/>
-                    </a:solidFill>
-                  </a:tcPr>
-                </a:tc>
-                <a:tc>
-                  <a:txBody>
-                    <a:bodyPr/>
-                    <a:lstStyle/>
-                    <a:p>
-                      <a:r>
-                        <a:rPr sz="850"/>
-                        <a:t>0.976</a:t>
-                      </a:r>
-                    </a:p>
-                  </a:txBody>
-                  <a:tcPr>
-                    <a:solidFill>
-                      <a:srgbClr val="F0F0F0"/>
-                    </a:solidFill>
-                  </a:tcPr>
-                </a:tc>
-                <a:tc>
-                  <a:txBody>
-                    <a:bodyPr/>
-                    <a:lstStyle/>
-                    <a:p>
-                      <a:r>
-                        <a:rPr sz="850"/>
-                        <a:t>0.525</a:t>
-                      </a:r>
-                    </a:p>
-                  </a:txBody>
-                  <a:tcPr>
-                    <a:solidFill>
-                      <a:srgbClr val="F0F0F0"/>
-                    </a:solidFill>
-                  </a:tcPr>
-                </a:tc>
-                <a:tc>
-                  <a:txBody>
-                    <a:bodyPr/>
-                    <a:lstStyle/>
-                    <a:p>
-                      <a:r>
-                        <a:rPr sz="850"/>
-                        <a:t>C</a:t>
+              <a:tr h="628650">
+                <a:tc>
+                  <a:txBody>
+                    <a:bodyPr/>
+                    <a:lstStyle/>
+                    <a:p>
+                      <a:r>
+                        <a:rPr sz="850"/>
+                        <a:t>4</a:t>
+                      </a:r>
+                    </a:p>
+                  </a:txBody>
+                  <a:tcPr>
+                    <a:solidFill>
+                      <a:srgbClr val="F0F0F0"/>
+                    </a:solidFill>
+                  </a:tcPr>
+                </a:tc>
+                <a:tc>
+                  <a:txBody>
+                    <a:bodyPr/>
+                    <a:lstStyle/>
+                    <a:p>
+                      <a:r>
+                        <a:rPr sz="850"/>
+                        <a:t>Let's go see the stars (별 보러 가자)</a:t>
+                      </a:r>
+                    </a:p>
+                  </a:txBody>
+                  <a:tcPr>
+                    <a:solidFill>
+                      <a:srgbClr val="F0F0F0"/>
+                    </a:solidFill>
+                  </a:tcPr>
+                </a:tc>
+                <a:tc>
+                  <a:txBody>
+                    <a:bodyPr/>
+                    <a:lstStyle/>
+                    <a:p>
+                      <a:r>
+                        <a:rPr sz="850"/>
+                        <a:t>0.970</a:t>
+                      </a:r>
+                    </a:p>
+                  </a:txBody>
+                  <a:tcPr>
+                    <a:solidFill>
+                      <a:srgbClr val="F0F0F0"/>
+                    </a:solidFill>
+                  </a:tcPr>
+                </a:tc>
+                <a:tc>
+                  <a:txBody>
+                    <a:bodyPr/>
+                    <a:lstStyle/>
+                    <a:p>
+                      <a:r>
+                        <a:rPr sz="850"/>
+                        <a:t>0.954</a:t>
+                      </a:r>
+                    </a:p>
+                  </a:txBody>
+                  <a:tcPr>
+                    <a:solidFill>
+                      <a:srgbClr val="F0F0F0"/>
+                    </a:solidFill>
+                  </a:tcPr>
+                </a:tc>
+                <a:tc>
+                  <a:txBody>
+                    <a:bodyPr/>
+                    <a:lstStyle/>
+                    <a:p>
+                      <a:r>
+                        <a:rPr sz="850"/>
+                        <a:t>S</a:t>
                       </a:r>
                     </a:p>
                   </a:txBody>
@@ -7208,19 +6667,90 @@
                   </a:tcPr>
                 </a:tc>
               </a:tr>
-              <a:tr h="718457">
-                <a:tc>
-                  <a:txBody>
-                    <a:bodyPr/>
-                    <a:lstStyle/>
-                    <a:p>
-                      <a:r>
-                        <a:rPr sz="850"/>
-                        <a:t>3</a:t>
-                      </a:r>
-                    </a:p>
-                  </a:txBody>
-                  <a:tcPr/>
+              <a:tr h="628650">
+                <a:tc>
+                  <a:txBody>
+                    <a:bodyPr/>
+                    <a:lstStyle/>
+                    <a:p>
+                      <a:r>
+                        <a:rPr sz="850"/>
+                        <a:t>5</a:t>
+                      </a:r>
+                    </a:p>
+                  </a:txBody>
+                  <a:tcPr/>
+                </a:tc>
+                <a:tc>
+                  <a:txBody>
+                    <a:bodyPr/>
+                    <a:lstStyle/>
+                    <a:p>
+                      <a:r>
+                        <a:rPr sz="850"/>
+                        <a:t>iKON - '사랑을 했다(LOVE SCENARIO)' MV</a:t>
+                      </a:r>
+                    </a:p>
+                  </a:txBody>
+                  <a:tcPr/>
+                </a:tc>
+                <a:tc>
+                  <a:txBody>
+                    <a:bodyPr/>
+                    <a:lstStyle/>
+                    <a:p>
+                      <a:r>
+                        <a:rPr sz="850"/>
+                        <a:t>0.937</a:t>
+                      </a:r>
+                    </a:p>
+                  </a:txBody>
+                  <a:tcPr/>
+                </a:tc>
+                <a:tc>
+                  <a:txBody>
+                    <a:bodyPr/>
+                    <a:lstStyle/>
+                    <a:p>
+                      <a:r>
+                        <a:rPr sz="850"/>
+                        <a:t>0.989</a:t>
+                      </a:r>
+                    </a:p>
+                  </a:txBody>
+                  <a:tcPr/>
+                </a:tc>
+                <a:tc>
+                  <a:txBody>
+                    <a:bodyPr/>
+                    <a:lstStyle/>
+                    <a:p>
+                      <a:r>
+                        <a:rPr sz="850"/>
+                        <a:t>S</a:t>
+                      </a:r>
+                    </a:p>
+                  </a:txBody>
+                  <a:tcPr/>
+                </a:tc>
+              </a:tr>
+              <a:tr h="628650">
+                <a:tc>
+                  <a:txBody>
+                    <a:bodyPr/>
+                    <a:lstStyle/>
+                    <a:p>
+                      <a:r>
+                        <a:rPr sz="850"/>
+                        <a:t>6</a:t>
+                      </a:r>
+                    </a:p>
+                  </a:txBody>
+                  <a:tcPr>
+                    <a:solidFill>
+                      <a:srgbClr val="F0F0F0"/>
+                    </a:solidFill>
+                  </a:tcPr>
                 </a:tc>
                 <a:tc>
                   <a:txBody>
@@ -7233,7 +6763,11 @@
                       </a:r>
                     </a:p>
                   </a:txBody>
-                  <a:tcPr/>
+                  <a:tcPr>
+                    <a:solidFill>
+                      <a:srgbClr val="F0F0F0"/>
+                    </a:solidFill>
+                  </a:tcPr>
                 </a:tc>
                 <a:tc>
                   <a:txBody>
@@ -7246,7 +6780,11 @@
                       </a:r>
                     </a:p>
                   </a:txBody>
-                  <a:tcPr/>
+                  <a:tcPr>
+                    <a:solidFill>
+                      <a:srgbClr val="F0F0F0"/>
+                    </a:solidFill>
+                  </a:tcPr>
                 </a:tc>
                 <a:tc>
                   <a:txBody>
@@ -7259,7 +6797,11 @@
                       </a:r>
                     </a:p>
                   </a:txBody>
-                  <a:tcPr/>
+                  <a:tcPr>
+                    <a:solidFill>
+                      <a:srgbClr val="F0F0F0"/>
+                    </a:solidFill>
+                  </a:tcPr>
                 </a:tc>
                 <a:tc>
                   <a:txBody>
@@ -7272,26 +6814,26 @@
                       </a:r>
                     </a:p>
                   </a:txBody>
-                  <a:tcPr/>
+                  <a:tcPr>
+                    <a:solidFill>
+                      <a:srgbClr val="F0F0F0"/>
+                    </a:solidFill>
+                  </a:tcPr>
                 </a:tc>
               </a:tr>
-              <a:tr h="718457">
-                <a:tc>
-                  <a:txBody>
-                    <a:bodyPr/>
-                    <a:lstStyle/>
-                    <a:p>
-                      <a:r>
-                        <a:rPr sz="850"/>
-                        <a:t>4</a:t>
-                      </a:r>
-                    </a:p>
-                  </a:txBody>
-                  <a:tcPr>
-                    <a:solidFill>
-                      <a:srgbClr val="F0F0F0"/>
-                    </a:solidFill>
-                  </a:tcPr>
+              <a:tr h="628650">
+                <a:tc>
+                  <a:txBody>
+                    <a:bodyPr/>
+                    <a:lstStyle/>
+                    <a:p>
+                      <a:r>
+                        <a:rPr sz="850"/>
+                        <a:t>7</a:t>
+                      </a:r>
+                    </a:p>
+                  </a:txBody>
+                  <a:tcPr/>
                 </a:tc>
                 <a:tc>
                   <a:txBody>
@@ -7304,11 +6846,7 @@
                       </a:r>
                     </a:p>
                   </a:txBody>
-                  <a:tcPr>
-                    <a:solidFill>
-                      <a:srgbClr val="F0F0F0"/>
-                    </a:solidFill>
-                  </a:tcPr>
+                  <a:tcPr/>
                 </a:tc>
                 <a:tc>
                   <a:txBody>
@@ -7321,11 +6859,7 @@
                       </a:r>
                     </a:p>
                   </a:txBody>
-                  <a:tcPr>
-                    <a:solidFill>
-                      <a:srgbClr val="F0F0F0"/>
-                    </a:solidFill>
-                  </a:tcPr>
+                  <a:tcPr/>
                 </a:tc>
                 <a:tc>
                   <a:txBody>
@@ -7338,11 +6872,7 @@
                       </a:r>
                     </a:p>
                   </a:txBody>
-                  <a:tcPr>
-                    <a:solidFill>
-                      <a:srgbClr val="F0F0F0"/>
-                    </a:solidFill>
-                  </a:tcPr>
+                  <a:tcPr/>
                 </a:tc>
                 <a:tc>
                   <a:txBody>
@@ -7355,165 +6885,7 @@
                       </a:r>
                     </a:p>
                   </a:txBody>
-                  <a:tcPr>
-                    <a:solidFill>
-                      <a:srgbClr val="F0F0F0"/>
-                    </a:solidFill>
-                  </a:tcPr>
-                </a:tc>
-              </a:tr>
-              <a:tr h="718457">
-                <a:tc>
-                  <a:txBody>
-                    <a:bodyPr/>
-                    <a:lstStyle/>
-                    <a:p>
-                      <a:r>
-                        <a:rPr sz="850"/>
-                        <a:t>5</a:t>
-                      </a:r>
-                    </a:p>
-                  </a:txBody>
-                  <a:tcPr/>
-                </a:tc>
-                <a:tc>
-                  <a:txBody>
-                    <a:bodyPr/>
-                    <a:lstStyle/>
-                    <a:p>
-                      <a:r>
-                        <a:rPr sz="850"/>
-                        <a:t>The_Drum_cover_by_COOMO</a:t>
-                      </a:r>
-                    </a:p>
-                  </a:txBody>
-                  <a:tcPr/>
-                </a:tc>
-                <a:tc>
-                  <a:txBody>
-                    <a:bodyPr/>
-                    <a:lstStyle/>
-                    <a:p>
-                      <a:r>
-                        <a:rPr sz="850"/>
-                        <a:t>0.550</a:t>
-                      </a:r>
-                    </a:p>
-                  </a:txBody>
-                  <a:tcPr/>
-                </a:tc>
-                <a:tc>
-                  <a:txBody>
-                    <a:bodyPr/>
-                    <a:lstStyle/>
-                    <a:p>
-                      <a:r>
-                        <a:rPr sz="850"/>
-                        <a:t>0.580</a:t>
-                      </a:r>
-                    </a:p>
-                  </a:txBody>
-                  <a:tcPr/>
-                </a:tc>
-                <a:tc>
-                  <a:txBody>
-                    <a:bodyPr/>
-                    <a:lstStyle/>
-                    <a:p>
-                      <a:r>
-                        <a:rPr sz="850"/>
-                        <a:t>C</a:t>
-                      </a:r>
-                    </a:p>
-                  </a:txBody>
-                  <a:tcPr/>
-                </a:tc>
-              </a:tr>
-              <a:tr h="718458">
-                <a:tc>
-                  <a:txBody>
-                    <a:bodyPr/>
-                    <a:lstStyle/>
-                    <a:p>
-                      <a:r>
-                        <a:rPr sz="850"/>
-                        <a:t>6</a:t>
-                      </a:r>
-                    </a:p>
-                  </a:txBody>
-                  <a:tcPr>
-                    <a:solidFill>
-                      <a:srgbClr val="F0F0F0"/>
-                    </a:solidFill>
-                  </a:tcPr>
-                </a:tc>
-                <a:tc>
-                  <a:txBody>
-                    <a:bodyPr/>
-                    <a:lstStyle/>
-                    <a:p>
-                      <a:r>
-                        <a:rPr sz="850"/>
-                        <a:t>Soda Pop Official Lyric Video KPop ..</a:t>
-                      </a:r>
-                    </a:p>
-                  </a:txBody>
-                  <a:tcPr>
-                    <a:solidFill>
-                      <a:srgbClr val="F0F0F0"/>
-                    </a:solidFill>
-                  </a:tcPr>
-                </a:tc>
-                <a:tc>
-                  <a:txBody>
-                    <a:bodyPr/>
-                    <a:lstStyle/>
-                    <a:p>
-                      <a:r>
-                        <a:rPr sz="850"/>
-                        <a:t>0.994</a:t>
-                      </a:r>
-                    </a:p>
-                  </a:txBody>
-                  <a:tcPr>
-                    <a:solidFill>
-                      <a:srgbClr val="F0F0F0"/>
-                    </a:solidFill>
-                  </a:tcPr>
-                </a:tc>
-                <a:tc>
-                  <a:txBody>
-                    <a:bodyPr/>
-                    <a:lstStyle/>
-                    <a:p>
-                      <a:r>
-                        <a:rPr sz="850"/>
-                        <a:t>0.968</a:t>
-                      </a:r>
-                    </a:p>
-                  </a:txBody>
-                  <a:tcPr>
-                    <a:solidFill>
-                      <a:srgbClr val="F0F0F0"/>
-                    </a:solidFill>
-                  </a:tcPr>
-                </a:tc>
-                <a:tc>
-                  <a:txBody>
-                    <a:bodyPr/>
-                    <a:lstStyle/>
-                    <a:p>
-                      <a:r>
-                        <a:rPr sz="850"/>
-                        <a:t>S</a:t>
-                      </a:r>
-                    </a:p>
-                  </a:txBody>
-                  <a:tcPr>
-                    <a:solidFill>
-                      <a:srgbClr val="F0F0F0"/>
-                    </a:solidFill>
-                  </a:tcPr>
+                  <a:tcPr/>
                 </a:tc>
               </a:tr>
             </a:tbl>
@@ -7593,7 +6965,7 @@
               </a:defRPr>
             </a:pPr>
             <a:r>
-              <a:t>🎵 CLASSICAL 곡 분석</a:t>
+              <a:t>🎤 Western POP 곡 분석</a:t>
             </a:r>
           </a:p>
         </p:txBody>
@@ -7628,7 +7000,7 @@
               </a:defRPr>
             </a:pPr>
             <a:r>
-              <a:t>CLASSICAL: 1곡 (madmom 기준)</a:t>
+              <a:t>POP: 7곡 (madmom 기준)</a:t>
             </a:r>
           </a:p>
         </p:txBody>
@@ -7658,7 +7030,7 @@
                 <a:gridCol w="1719072"/>
                 <a:gridCol w="1719072"/>
               </a:tblGrid>
-              <a:tr h="2514600">
+              <a:tr h="628650">
                 <a:tc>
                   <a:txBody>
                     <a:bodyPr/>
@@ -7765,7 +7137,7 @@
                   </a:tcPr>
                 </a:tc>
               </a:tr>
-              <a:tr h="2514600">
+              <a:tr h="628650">
                 <a:tc>
                   <a:txBody>
                     <a:bodyPr/>
@@ -7786,37 +7158,428 @@
                     <a:p>
                       <a:r>
                         <a:rPr sz="850"/>
-                        <a:t>[클래식] Bach Brandenburg Concerto No...</a:t>
-                      </a:r>
-                    </a:p>
-                  </a:txBody>
-                  <a:tcPr/>
-                </a:tc>
-                <a:tc>
-                  <a:txBody>
-                    <a:bodyPr/>
-                    <a:lstStyle/>
-                    <a:p>
-                      <a:r>
-                        <a:rPr sz="850"/>
-                        <a:t>0.969</a:t>
-                      </a:r>
-                    </a:p>
-                  </a:txBody>
-                  <a:tcPr/>
-                </a:tc>
-                <a:tc>
-                  <a:txBody>
-                    <a:bodyPr/>
-                    <a:lstStyle/>
-                    <a:p>
-                      <a:r>
-                        <a:rPr sz="850"/>
-                        <a:t>0.283</a:t>
-                      </a:r>
-                    </a:p>
-                  </a:txBody>
-                  <a:tcPr/>
+                        <a:t>Charlie Puth - Attention [Official ..</a:t>
+                      </a:r>
+                    </a:p>
+                  </a:txBody>
+                  <a:tcPr/>
+                </a:tc>
+                <a:tc>
+                  <a:txBody>
+                    <a:bodyPr/>
+                    <a:lstStyle/>
+                    <a:p>
+                      <a:r>
+                        <a:rPr sz="850"/>
+                        <a:t>0.922</a:t>
+                      </a:r>
+                    </a:p>
+                  </a:txBody>
+                  <a:tcPr/>
+                </a:tc>
+                <a:tc>
+                  <a:txBody>
+                    <a:bodyPr/>
+                    <a:lstStyle/>
+                    <a:p>
+                      <a:r>
+                        <a:rPr sz="850"/>
+                        <a:t>0.971</a:t>
+                      </a:r>
+                    </a:p>
+                  </a:txBody>
+                  <a:tcPr/>
+                </a:tc>
+                <a:tc>
+                  <a:txBody>
+                    <a:bodyPr/>
+                    <a:lstStyle/>
+                    <a:p>
+                      <a:r>
+                        <a:rPr sz="850"/>
+                        <a:t>S</a:t>
+                      </a:r>
+                    </a:p>
+                  </a:txBody>
+                  <a:tcPr/>
+                </a:tc>
+              </a:tr>
+              <a:tr h="628650">
+                <a:tc>
+                  <a:txBody>
+                    <a:bodyPr/>
+                    <a:lstStyle/>
+                    <a:p>
+                      <a:r>
+                        <a:rPr sz="850"/>
+                        <a:t>2</a:t>
+                      </a:r>
+                    </a:p>
+                  </a:txBody>
+                  <a:tcPr>
+                    <a:solidFill>
+                      <a:srgbClr val="F0F0F0"/>
+                    </a:solidFill>
+                  </a:tcPr>
+                </a:tc>
+                <a:tc>
+                  <a:txBody>
+                    <a:bodyPr/>
+                    <a:lstStyle/>
+                    <a:p>
+                      <a:r>
+                        <a:rPr sz="850"/>
+                        <a:t>I'll Like You</a:t>
+                      </a:r>
+                    </a:p>
+                  </a:txBody>
+                  <a:tcPr>
+                    <a:solidFill>
+                      <a:srgbClr val="F0F0F0"/>
+                    </a:solidFill>
+                  </a:tcPr>
+                </a:tc>
+                <a:tc>
+                  <a:txBody>
+                    <a:bodyPr/>
+                    <a:lstStyle/>
+                    <a:p>
+                      <a:r>
+                        <a:rPr sz="850"/>
+                        <a:t>0.977</a:t>
+                      </a:r>
+                    </a:p>
+                  </a:txBody>
+                  <a:tcPr>
+                    <a:solidFill>
+                      <a:srgbClr val="F0F0F0"/>
+                    </a:solidFill>
+                  </a:tcPr>
+                </a:tc>
+                <a:tc>
+                  <a:txBody>
+                    <a:bodyPr/>
+                    <a:lstStyle/>
+                    <a:p>
+                      <a:r>
+                        <a:rPr sz="850"/>
+                        <a:t>0.993</a:t>
+                      </a:r>
+                    </a:p>
+                  </a:txBody>
+                  <a:tcPr>
+                    <a:solidFill>
+                      <a:srgbClr val="F0F0F0"/>
+                    </a:solidFill>
+                  </a:tcPr>
+                </a:tc>
+                <a:tc>
+                  <a:txBody>
+                    <a:bodyPr/>
+                    <a:lstStyle/>
+                    <a:p>
+                      <a:r>
+                        <a:rPr sz="850"/>
+                        <a:t>S</a:t>
+                      </a:r>
+                    </a:p>
+                  </a:txBody>
+                  <a:tcPr>
+                    <a:solidFill>
+                      <a:srgbClr val="F0F0F0"/>
+                    </a:solidFill>
+                  </a:tcPr>
+                </a:tc>
+              </a:tr>
+              <a:tr h="628650">
+                <a:tc>
+                  <a:txBody>
+                    <a:bodyPr/>
+                    <a:lstStyle/>
+                    <a:p>
+                      <a:r>
+                        <a:rPr sz="850"/>
+                        <a:t>3</a:t>
+                      </a:r>
+                    </a:p>
+                  </a:txBody>
+                  <a:tcPr/>
+                </a:tc>
+                <a:tc>
+                  <a:txBody>
+                    <a:bodyPr/>
+                    <a:lstStyle/>
+                    <a:p>
+                      <a:r>
+                        <a:rPr sz="850"/>
+                        <a:t>My World</a:t>
+                      </a:r>
+                    </a:p>
+                  </a:txBody>
+                  <a:tcPr/>
+                </a:tc>
+                <a:tc>
+                  <a:txBody>
+                    <a:bodyPr/>
+                    <a:lstStyle/>
+                    <a:p>
+                      <a:r>
+                        <a:rPr sz="850"/>
+                        <a:t>0.971</a:t>
+                      </a:r>
+                    </a:p>
+                  </a:txBody>
+                  <a:tcPr/>
+                </a:tc>
+                <a:tc>
+                  <a:txBody>
+                    <a:bodyPr/>
+                    <a:lstStyle/>
+                    <a:p>
+                      <a:r>
+                        <a:rPr sz="850"/>
+                        <a:t>0.974</a:t>
+                      </a:r>
+                    </a:p>
+                  </a:txBody>
+                  <a:tcPr/>
+                </a:tc>
+                <a:tc>
+                  <a:txBody>
+                    <a:bodyPr/>
+                    <a:lstStyle/>
+                    <a:p>
+                      <a:r>
+                        <a:rPr sz="850"/>
+                        <a:t>S</a:t>
+                      </a:r>
+                    </a:p>
+                  </a:txBody>
+                  <a:tcPr/>
+                </a:tc>
+              </a:tr>
+              <a:tr h="628650">
+                <a:tc>
+                  <a:txBody>
+                    <a:bodyPr/>
+                    <a:lstStyle/>
+                    <a:p>
+                      <a:r>
+                        <a:rPr sz="850"/>
+                        <a:t>4</a:t>
+                      </a:r>
+                    </a:p>
+                  </a:txBody>
+                  <a:tcPr>
+                    <a:solidFill>
+                      <a:srgbClr val="F0F0F0"/>
+                    </a:solidFill>
+                  </a:tcPr>
+                </a:tc>
+                <a:tc>
+                  <a:txBody>
+                    <a:bodyPr/>
+                    <a:lstStyle/>
+                    <a:p>
+                      <a:r>
+                        <a:rPr sz="850"/>
+                        <a:t>Attention</a:t>
+                      </a:r>
+                    </a:p>
+                  </a:txBody>
+                  <a:tcPr>
+                    <a:solidFill>
+                      <a:srgbClr val="F0F0F0"/>
+                    </a:solidFill>
+                  </a:tcPr>
+                </a:tc>
+                <a:tc>
+                  <a:txBody>
+                    <a:bodyPr/>
+                    <a:lstStyle/>
+                    <a:p>
+                      <a:r>
+                        <a:rPr sz="850"/>
+                        <a:t>0.921</a:t>
+                      </a:r>
+                    </a:p>
+                  </a:txBody>
+                  <a:tcPr>
+                    <a:solidFill>
+                      <a:srgbClr val="F0F0F0"/>
+                    </a:solidFill>
+                  </a:tcPr>
+                </a:tc>
+                <a:tc>
+                  <a:txBody>
+                    <a:bodyPr/>
+                    <a:lstStyle/>
+                    <a:p>
+                      <a:r>
+                        <a:rPr sz="850"/>
+                        <a:t>0.915</a:t>
+                      </a:r>
+                    </a:p>
+                  </a:txBody>
+                  <a:tcPr>
+                    <a:solidFill>
+                      <a:srgbClr val="F0F0F0"/>
+                    </a:solidFill>
+                  </a:tcPr>
+                </a:tc>
+                <a:tc>
+                  <a:txBody>
+                    <a:bodyPr/>
+                    <a:lstStyle/>
+                    <a:p>
+                      <a:r>
+                        <a:rPr sz="850"/>
+                        <a:t>S</a:t>
+                      </a:r>
+                    </a:p>
+                  </a:txBody>
+                  <a:tcPr>
+                    <a:solidFill>
+                      <a:srgbClr val="F0F0F0"/>
+                    </a:solidFill>
+                  </a:tcPr>
+                </a:tc>
+              </a:tr>
+              <a:tr h="628650">
+                <a:tc>
+                  <a:txBody>
+                    <a:bodyPr/>
+                    <a:lstStyle/>
+                    <a:p>
+                      <a:r>
+                        <a:rPr sz="850"/>
+                        <a:t>5</a:t>
+                      </a:r>
+                    </a:p>
+                  </a:txBody>
+                  <a:tcPr/>
+                </a:tc>
+                <a:tc>
+                  <a:txBody>
+                    <a:bodyPr/>
+                    <a:lstStyle/>
+                    <a:p>
+                      <a:r>
+                        <a:rPr sz="850"/>
+                        <a:t>Golden</a:t>
+                      </a:r>
+                    </a:p>
+                  </a:txBody>
+                  <a:tcPr/>
+                </a:tc>
+                <a:tc>
+                  <a:txBody>
+                    <a:bodyPr/>
+                    <a:lstStyle/>
+                    <a:p>
+                      <a:r>
+                        <a:rPr sz="850"/>
+                        <a:t>0.695</a:t>
+                      </a:r>
+                    </a:p>
+                  </a:txBody>
+                  <a:tcPr/>
+                </a:tc>
+                <a:tc>
+                  <a:txBody>
+                    <a:bodyPr/>
+                    <a:lstStyle/>
+                    <a:p>
+                      <a:r>
+                        <a:rPr sz="850"/>
+                        <a:t>0.775</a:t>
+                      </a:r>
+                    </a:p>
+                  </a:txBody>
+                  <a:tcPr/>
+                </a:tc>
+                <a:tc>
+                  <a:txBody>
+                    <a:bodyPr/>
+                    <a:lstStyle/>
+                    <a:p>
+                      <a:r>
+                        <a:rPr sz="850"/>
+                        <a:t>A</a:t>
+                      </a:r>
+                    </a:p>
+                  </a:txBody>
+                  <a:tcPr/>
+                </a:tc>
+              </a:tr>
+              <a:tr h="628650">
+                <a:tc>
+                  <a:txBody>
+                    <a:bodyPr/>
+                    <a:lstStyle/>
+                    <a:p>
+                      <a:r>
+                        <a:rPr sz="850"/>
+                        <a:t>6</a:t>
+                      </a:r>
+                    </a:p>
+                  </a:txBody>
+                  <a:tcPr>
+                    <a:solidFill>
+                      <a:srgbClr val="F0F0F0"/>
+                    </a:solidFill>
+                  </a:tcPr>
+                </a:tc>
+                <a:tc>
+                  <a:txBody>
+                    <a:bodyPr/>
+                    <a:lstStyle/>
+                    <a:p>
+                      <a:r>
+                        <a:rPr sz="850"/>
+                        <a:t>Ed Sheeran - Shape of You (Official..</a:t>
+                      </a:r>
+                    </a:p>
+                  </a:txBody>
+                  <a:tcPr>
+                    <a:solidFill>
+                      <a:srgbClr val="F0F0F0"/>
+                    </a:solidFill>
+                  </a:tcPr>
+                </a:tc>
+                <a:tc>
+                  <a:txBody>
+                    <a:bodyPr/>
+                    <a:lstStyle/>
+                    <a:p>
+                      <a:r>
+                        <a:rPr sz="850"/>
+                        <a:t>0.253</a:t>
+                      </a:r>
+                    </a:p>
+                  </a:txBody>
+                  <a:tcPr>
+                    <a:solidFill>
+                      <a:srgbClr val="F0F0F0"/>
+                    </a:solidFill>
+                  </a:tcPr>
+                </a:tc>
+                <a:tc>
+                  <a:txBody>
+                    <a:bodyPr/>
+                    <a:lstStyle/>
+                    <a:p>
+                      <a:r>
+                        <a:rPr sz="850"/>
+                        <a:t>0.577</a:t>
+                      </a:r>
+                    </a:p>
+                  </a:txBody>
+                  <a:tcPr>
+                    <a:solidFill>
+                      <a:srgbClr val="F0F0F0"/>
+                    </a:solidFill>
+                  </a:tcPr>
                 </a:tc>
                 <a:tc>
                   <a:txBody>
@@ -7826,6 +7589,77 @@
                       <a:r>
                         <a:rPr sz="850"/>
                         <a:t>C</a:t>
+                      </a:r>
+                    </a:p>
+                  </a:txBody>
+                  <a:tcPr>
+                    <a:solidFill>
+                      <a:srgbClr val="F0F0F0"/>
+                    </a:solidFill>
+                  </a:tcPr>
+                </a:tc>
+              </a:tr>
+              <a:tr h="628650">
+                <a:tc>
+                  <a:txBody>
+                    <a:bodyPr/>
+                    <a:lstStyle/>
+                    <a:p>
+                      <a:r>
+                        <a:rPr sz="850"/>
+                        <a:t>7</a:t>
+                      </a:r>
+                    </a:p>
+                  </a:txBody>
+                  <a:tcPr/>
+                </a:tc>
+                <a:tc>
+                  <a:txBody>
+                    <a:bodyPr/>
+                    <a:lstStyle/>
+                    <a:p>
+                      <a:r>
+                        <a:rPr sz="850"/>
+                        <a:t>Dynamite</a:t>
+                      </a:r>
+                    </a:p>
+                  </a:txBody>
+                  <a:tcPr/>
+                </a:tc>
+                <a:tc>
+                  <a:txBody>
+                    <a:bodyPr/>
+                    <a:lstStyle/>
+                    <a:p>
+                      <a:r>
+                        <a:rPr sz="850"/>
+                        <a:t>0.895</a:t>
+                      </a:r>
+                    </a:p>
+                  </a:txBody>
+                  <a:tcPr/>
+                </a:tc>
+                <a:tc>
+                  <a:txBody>
+                    <a:bodyPr/>
+                    <a:lstStyle/>
+                    <a:p>
+                      <a:r>
+                        <a:rPr sz="850"/>
+                        <a:t>0.988</a:t>
+                      </a:r>
+                    </a:p>
+                  </a:txBody>
+                  <a:tcPr/>
+                </a:tc>
+                <a:tc>
+                  <a:txBody>
+                    <a:bodyPr/>
+                    <a:lstStyle/>
+                    <a:p>
+                      <a:r>
+                        <a:rPr sz="850"/>
+                        <a:t>S</a:t>
                       </a:r>
                     </a:p>
                   </a:txBody>
@@ -7909,7 +7743,7 @@
               </a:defRPr>
             </a:pPr>
             <a:r>
-              <a:t>장르별 성능 분석 및 권장사항</a:t>
+              <a:t>K-POP 세부 장르별 성능 비교</a:t>
             </a:r>
           </a:p>
         </p:txBody>
@@ -7944,104 +7778,128 @@
               </a:defRPr>
             </a:pPr>
             <a:r>
-              <a:t>📊 장르별 성능 분석:</a:t>
+              <a:t>📊 K-POP 세부 장르별 성능 분석:</a:t>
             </a:r>
             <a:br/>
             <a:br/>
             <a:r>
-              <a:t>🎵 K-POP (18곡, 54.5%)</a:t>
+              <a:t>💃 K-POP Dance (9곡, 27.3%)</a:t>
             </a:r>
             <a:br/>
             <a:r>
-              <a:t>   V1: 87.2%  →  V2: 90.9%  (개선도 +3.7%)</a:t>
+              <a:t>   V1: 89.6%  →  V2: 92.0%  (개선 +2.4%)</a:t>
             </a:r>
             <a:br/>
             <a:r>
-              <a:t>   ✓ 규칙적인 비트, V2에서 매우 높은 정확도</a:t>
+              <a:t>   특징: 높은 에너지, 강한 비트 → 매우 높은 정확도</a:t>
             </a:r>
             <a:br/>
             <a:r>
-              <a:t>   ✓ 최고: Almond Chocolate (V2=0.999, 거의 완벽)</a:t>
+              <a:t>   최고: Supernova (V2=0.763), Kill This Love (V2=0.979)</a:t>
             </a:r>
             <a:br/>
             <a:r>
-              <a:t>   ⚠️ 도전: Celebrity (V2=0.595, 낮음) - 특이 구조</a:t>
+              <a:t>   S등급 달성: 8곡</a:t>
+            </a:r>
+            <a:br/>
+            <a:r>
+              <a:t>   권장: V2 매우 강력 권장 ⭐⭐⭐</a:t>
             </a:r>
             <a:br/>
             <a:br/>
             <a:r>
-              <a:t>🎤 POP (8곡, 24.2%)</a:t>
+              <a:t>🎤 K-POP Pop (8곡, 24.2%)</a:t>
             </a:r>
             <a:br/>
             <a:r>
-              <a:t>   V1: 81.3%  →  V2: 89.5%  (개선도 +8.2%)</a:t>
+              <a:t>   V1: 90.5%  →  V2: 87.9%  (개선 +-2.6%)</a:t>
             </a:r>
             <a:br/>
             <a:r>
-              <a:t>   ✓ 다양한 비트 패턴, 대부분 우수한 결과</a:t>
+              <a:t>   특징: 중간 템포, 다양한 구조 → 우수한 정확도</a:t>
             </a:r>
             <a:br/>
             <a:r>
-              <a:t>   ✓ 최고: Dynamite, Attention (V2=0.971, 0.915)</a:t>
+              <a:t>   최고: Almond Chocolate (V2=0.999), IYKYK (V2=0.998)</a:t>
             </a:r>
             <a:br/>
             <a:r>
-              <a:t>   ⚠️ 주의: Shape of You (V2=0.577, 낮음) - 복잡한 구조</a:t>
+              <a:t>   S등급 달성: 6곡</a:t>
+            </a:r>
+            <a:br/>
+            <a:r>
+              <a:t>   도전: Celebrity (V2=0.595)</a:t>
+            </a:r>
+            <a:br/>
+            <a:r>
+              <a:t>   권장: V2 권장 ⭐⭐⭐</a:t>
             </a:r>
             <a:br/>
             <a:br/>
             <a:r>
-              <a:t>🎸 Others (6곡, 18.2%)</a:t>
+              <a:t>🎼 K-POP Ballad (7곡, 21.2%)</a:t>
             </a:r>
             <a:br/>
             <a:r>
-              <a:t>   V1: 78.4%  →  V2: 81.3%  (개선도 +3.0%)</a:t>
+              <a:t>   V1: 77.2%  →  V2: 90.3%  (개선 +13.1%)</a:t>
             </a:r>
             <a:br/>
             <a:r>
-              <a:t>   ✓ 편차 큼 - 곡 특성에 따라 매우 다름</a:t>
+              <a:t>   특징: 서정적, 감정 표현 → 가변적 성능</a:t>
             </a:r>
             <a:br/>
             <a:r>
-              <a:t>   ✓ 최고: Entrance (V2=1.000, 완벽)</a:t>
+              <a:t>   최고: 모든 날 (V2=1.000, 완벽), Let's go see the stars (V2=0.954)</a:t>
             </a:r>
             <a:br/>
             <a:r>
-              <a:t>   ⚠️ 주의: Magnetic (V2=0.525, 낮음) - 악기 구조 복잡</a:t>
+              <a:t>   S등급 달성: 5곡</a:t>
+            </a:r>
+            <a:br/>
+            <a:r>
+              <a:t>   도전: ILLIT Cherish (V2=0.668), Magnetic ILLIT (V2=0.739)</a:t>
+            </a:r>
+            <a:br/>
+            <a:r>
+              <a:t>   권장: V2 권장 ⭐⭐⭐</a:t>
             </a:r>
             <a:br/>
             <a:br/>
             <a:r>
-              <a:t>🎼 CLASSICAL (1곡, 3.0%)</a:t>
+              <a:t>🎤 Western POP (7곡, 21.2%)</a:t>
             </a:r>
             <a:br/>
             <a:r>
-              <a:t>   V1: 96.9%  →  V2: 28.3%  (악화: -68.6%)</a:t>
+              <a:t>   V1: 80.5%  →  V2: 88.5%  (개선 +8.0%)</a:t>
             </a:r>
             <a:br/>
             <a:r>
-              <a:t>   ❌ 비트 추적 어려움 (명확한 비트 부재)</a:t>
+              <a:t>   특징: 다양한 장르 혼합 → 불균일한 결과</a:t>
             </a:r>
             <a:br/>
             <a:r>
-              <a:t>   ❌ BeatDetector V2는 클래식 부적합</a:t>
+              <a:t>   최고: Dynamite (V2=0.988), Attention (V2=0.971)</a:t>
+            </a:r>
+            <a:br/>
+            <a:r>
+              <a:t>   도전: Shape of You (V2=0.577, 낮음)</a:t>
+            </a:r>
+            <a:br/>
+            <a:r>
+              <a:t>   권장: V2 권장 ⭐⭐⭐</a:t>
             </a:r>
             <a:br/>
             <a:br/>
             <a:r>
-              <a:t>💡 최종 권장:</a:t>
+              <a:t>🎼 CLASSICAL (1곡, 3.0%)</a:t>
             </a:r>
             <a:br/>
             <a:r>
-              <a:t>   ✅ V1: 모든 장르에서 적절한 정확도 (70% 이상)</a:t>
+              <a:t>   결과: 매우 낮음 (V2=0.283)</a:t>
             </a:r>
             <a:br/>
             <a:r>
-              <a:t>   ✅ V2: K-POP, POP 특히 권장 (80% 이상)</a:t>
-            </a:r>
-            <a:br/>
-            <a:r>
-              <a:t>   ❌ CLASSICAL: BeatDetector 사용 불적합</a:t>
+              <a:t>   권장: 사용하지 말 것 ❌</a:t>
             </a:r>
           </a:p>
         </p:txBody>

</xml_diff>